<commit_message>
added week2 slide 1 and slide 2
</commit_message>
<xml_diff>
--- a/teaching/slides/Chapter 2 - Specification-based testing.pptx
+++ b/teaching/slides/Chapter 2 - Specification-based testing.pptx
@@ -5,7 +5,7 @@
     <p:sldMasterId id="2147483659" r:id="rId1"/>
   </p:sldMasterIdLst>
   <p:notesMasterIdLst>
-    <p:notesMasterId r:id="rId25"/>
+    <p:notesMasterId r:id="rId44"/>
   </p:notesMasterIdLst>
   <p:sldIdLst>
     <p:sldId id="256" r:id="rId2"/>
@@ -31,26 +31,45 @@
     <p:sldId id="280" r:id="rId22"/>
     <p:sldId id="281" r:id="rId23"/>
     <p:sldId id="282" r:id="rId24"/>
+    <p:sldId id="283" r:id="rId25"/>
+    <p:sldId id="284" r:id="rId26"/>
+    <p:sldId id="285" r:id="rId27"/>
+    <p:sldId id="286" r:id="rId28"/>
+    <p:sldId id="287" r:id="rId29"/>
+    <p:sldId id="288" r:id="rId30"/>
+    <p:sldId id="289" r:id="rId31"/>
+    <p:sldId id="290" r:id="rId32"/>
+    <p:sldId id="291" r:id="rId33"/>
+    <p:sldId id="292" r:id="rId34"/>
+    <p:sldId id="293" r:id="rId35"/>
+    <p:sldId id="295" r:id="rId36"/>
+    <p:sldId id="294" r:id="rId37"/>
+    <p:sldId id="296" r:id="rId38"/>
+    <p:sldId id="297" r:id="rId39"/>
+    <p:sldId id="298" r:id="rId40"/>
+    <p:sldId id="299" r:id="rId41"/>
+    <p:sldId id="300" r:id="rId42"/>
+    <p:sldId id="301" r:id="rId43"/>
   </p:sldIdLst>
   <p:sldSz cx="9144000" cy="5143500" type="screen16x9"/>
   <p:notesSz cx="6858000" cy="9144000"/>
   <p:embeddedFontLst>
     <p:embeddedFont>
       <p:font typeface="Catamaran" panose="020B0604020202020204" charset="0"/>
-      <p:regular r:id="rId26"/>
-      <p:bold r:id="rId27"/>
+      <p:regular r:id="rId45"/>
+      <p:bold r:id="rId46"/>
     </p:embeddedFont>
     <p:embeddedFont>
       <p:font typeface="Quicksand" panose="020B0604020202020204" charset="0"/>
-      <p:regular r:id="rId28"/>
-      <p:bold r:id="rId29"/>
+      <p:regular r:id="rId47"/>
+      <p:bold r:id="rId48"/>
     </p:embeddedFont>
     <p:embeddedFont>
       <p:font typeface="Sarabun" panose="020B0604020202020204" charset="-34"/>
-      <p:regular r:id="rId30"/>
-      <p:bold r:id="rId31"/>
-      <p:italic r:id="rId32"/>
-      <p:boldItalic r:id="rId33"/>
+      <p:regular r:id="rId49"/>
+      <p:bold r:id="rId50"/>
+      <p:italic r:id="rId51"/>
+      <p:boldItalic r:id="rId52"/>
     </p:embeddedFont>
   </p:embeddedFontLst>
   <p:defaultTextStyle>
@@ -2290,7 +2309,7 @@
               </a:spcAft>
               <a:buNone/>
             </a:pPr>
-            <a:endParaRPr/>
+            <a:endParaRPr dirty="0"/>
           </a:p>
         </p:txBody>
       </p:sp>
@@ -10591,10 +10610,9 @@
               <a:t>testfile</a:t>
             </a:r>
             <a:r>
-              <a:rPr lang="en-US"/>
+              <a:rPr lang="en-US" dirty="0"/>
               <a:t>.</a:t>
             </a:r>
-            <a:endParaRPr lang="en-US" dirty="0"/>
           </a:p>
         </p:txBody>
       </p:sp>
@@ -10602,6 +10620,857 @@
     <p:extLst>
       <p:ext uri="{BB962C8B-B14F-4D97-AF65-F5344CB8AC3E}">
         <p14:creationId xmlns:p14="http://schemas.microsoft.com/office/powerpoint/2010/main" val="4101145361"/>
+      </p:ext>
+    </p:extLst>
+  </p:cSld>
+  <p:clrMapOvr>
+    <a:masterClrMapping/>
+  </p:clrMapOvr>
+</p:sld>
+</file>
+
+<file path=ppt/slides/slide24.xml><?xml version="1.0" encoding="utf-8"?>
+<p:sld xmlns:a="http://schemas.openxmlformats.org/drawingml/2006/main" xmlns:r="http://schemas.openxmlformats.org/officeDocument/2006/relationships" xmlns:p="http://schemas.openxmlformats.org/presentationml/2006/main">
+  <p:cSld>
+    <p:spTree>
+      <p:nvGrpSpPr>
+        <p:cNvPr id="1" name=""/>
+        <p:cNvGrpSpPr/>
+        <p:nvPr/>
+      </p:nvGrpSpPr>
+      <p:grpSpPr>
+        <a:xfrm>
+          <a:off x="0" y="0"/>
+          <a:ext cx="0" cy="0"/>
+          <a:chOff x="0" y="0"/>
+          <a:chExt cx="0" cy="0"/>
+        </a:xfrm>
+      </p:grpSpPr>
+      <p:sp>
+        <p:nvSpPr>
+          <p:cNvPr id="2" name="Title 1">
+            <a:extLst>
+              <a:ext uri="{FF2B5EF4-FFF2-40B4-BE49-F238E27FC236}">
+                <a16:creationId xmlns:a16="http://schemas.microsoft.com/office/drawing/2014/main" id="{BD335649-71C8-3808-375E-2A403E746277}"/>
+              </a:ext>
+            </a:extLst>
+          </p:cNvPr>
+          <p:cNvSpPr>
+            <a:spLocks noGrp="1"/>
+          </p:cNvSpPr>
+          <p:nvPr>
+            <p:ph type="title"/>
+          </p:nvPr>
+        </p:nvSpPr>
+        <p:spPr/>
+        <p:txBody>
+          <a:bodyPr>
+            <a:normAutofit fontScale="90000"/>
+          </a:bodyPr>
+          <a:lstStyle/>
+          <a:p>
+            <a:r>
+              <a:rPr lang="en-US" dirty="0"/>
+              <a:t>Input Space Coverage (ISP)</a:t>
+            </a:r>
+          </a:p>
+        </p:txBody>
+      </p:sp>
+      <p:sp>
+        <p:nvSpPr>
+          <p:cNvPr id="3" name="Text Placeholder 2">
+            <a:extLst>
+              <a:ext uri="{FF2B5EF4-FFF2-40B4-BE49-F238E27FC236}">
+                <a16:creationId xmlns:a16="http://schemas.microsoft.com/office/drawing/2014/main" id="{41F4FC71-AAFF-F201-CA3E-2EF1C7B6F20D}"/>
+              </a:ext>
+            </a:extLst>
+          </p:cNvPr>
+          <p:cNvSpPr>
+            <a:spLocks noGrp="1"/>
+          </p:cNvSpPr>
+          <p:nvPr>
+            <p:ph type="body" idx="1"/>
+          </p:nvPr>
+        </p:nvSpPr>
+        <p:spPr/>
+        <p:txBody>
+          <a:bodyPr/>
+          <a:lstStyle/>
+          <a:p>
+            <a:r>
+              <a:rPr lang="en-US" dirty="0"/>
+              <a:t>Equally applicable at several levels of testing</a:t>
+            </a:r>
+          </a:p>
+          <a:p>
+            <a:pPr lvl="1"/>
+            <a:r>
+              <a:rPr lang="en-US" dirty="0"/>
+              <a:t>Unit</a:t>
+            </a:r>
+          </a:p>
+          <a:p>
+            <a:pPr lvl="1"/>
+            <a:r>
+              <a:rPr lang="en-US" dirty="0"/>
+              <a:t>Integration</a:t>
+            </a:r>
+          </a:p>
+          <a:p>
+            <a:pPr lvl="1"/>
+            <a:r>
+              <a:rPr lang="en-US" dirty="0"/>
+              <a:t>System</a:t>
+            </a:r>
+          </a:p>
+          <a:p>
+            <a:r>
+              <a:rPr lang="en-US" dirty="0"/>
+              <a:t>Easy to apply with no automation</a:t>
+            </a:r>
+          </a:p>
+          <a:p>
+            <a:r>
+              <a:rPr lang="en-US" dirty="0"/>
+              <a:t>Can adjust the procedure to get more or fewer tests</a:t>
+            </a:r>
+          </a:p>
+          <a:p>
+            <a:r>
+              <a:rPr lang="en-US" dirty="0"/>
+              <a:t>No implementation knowledge is needed</a:t>
+            </a:r>
+          </a:p>
+          <a:p>
+            <a:pPr lvl="1"/>
+            <a:r>
+              <a:rPr lang="en-US" dirty="0"/>
+              <a:t>Just the input space</a:t>
+            </a:r>
+          </a:p>
+          <a:p>
+            <a:endParaRPr lang="en-US" dirty="0"/>
+          </a:p>
+        </p:txBody>
+      </p:sp>
+    </p:spTree>
+    <p:extLst>
+      <p:ext uri="{BB962C8B-B14F-4D97-AF65-F5344CB8AC3E}">
+        <p14:creationId xmlns:p14="http://schemas.microsoft.com/office/powerpoint/2010/main" val="1008622653"/>
+      </p:ext>
+    </p:extLst>
+  </p:cSld>
+  <p:clrMapOvr>
+    <a:masterClrMapping/>
+  </p:clrMapOvr>
+</p:sld>
+</file>
+
+<file path=ppt/slides/slide25.xml><?xml version="1.0" encoding="utf-8"?>
+<p:sld xmlns:a="http://schemas.openxmlformats.org/drawingml/2006/main" xmlns:r="http://schemas.openxmlformats.org/officeDocument/2006/relationships" xmlns:p="http://schemas.openxmlformats.org/presentationml/2006/main">
+  <p:cSld>
+    <p:spTree>
+      <p:nvGrpSpPr>
+        <p:cNvPr id="1" name=""/>
+        <p:cNvGrpSpPr/>
+        <p:nvPr/>
+      </p:nvGrpSpPr>
+      <p:grpSpPr>
+        <a:xfrm>
+          <a:off x="0" y="0"/>
+          <a:ext cx="0" cy="0"/>
+          <a:chOff x="0" y="0"/>
+          <a:chExt cx="0" cy="0"/>
+        </a:xfrm>
+      </p:grpSpPr>
+      <p:sp>
+        <p:nvSpPr>
+          <p:cNvPr id="2" name="Title 1">
+            <a:extLst>
+              <a:ext uri="{FF2B5EF4-FFF2-40B4-BE49-F238E27FC236}">
+                <a16:creationId xmlns:a16="http://schemas.microsoft.com/office/drawing/2014/main" id="{A6965569-798F-D6C3-2A47-931D9558CA01}"/>
+              </a:ext>
+            </a:extLst>
+          </p:cNvPr>
+          <p:cNvSpPr>
+            <a:spLocks noGrp="1"/>
+          </p:cNvSpPr>
+          <p:nvPr>
+            <p:ph type="title"/>
+          </p:nvPr>
+        </p:nvSpPr>
+        <p:spPr/>
+        <p:txBody>
+          <a:bodyPr>
+            <a:normAutofit fontScale="90000"/>
+          </a:bodyPr>
+          <a:lstStyle/>
+          <a:p>
+            <a:r>
+              <a:rPr lang="en-US" dirty="0"/>
+              <a:t>Input Domains</a:t>
+            </a:r>
+          </a:p>
+        </p:txBody>
+      </p:sp>
+      <p:sp>
+        <p:nvSpPr>
+          <p:cNvPr id="3" name="Text Placeholder 2">
+            <a:extLst>
+              <a:ext uri="{FF2B5EF4-FFF2-40B4-BE49-F238E27FC236}">
+                <a16:creationId xmlns:a16="http://schemas.microsoft.com/office/drawing/2014/main" id="{38391978-4CBA-9DB6-1087-CA48CFE25078}"/>
+              </a:ext>
+            </a:extLst>
+          </p:cNvPr>
+          <p:cNvSpPr>
+            <a:spLocks noGrp="1"/>
+          </p:cNvSpPr>
+          <p:nvPr>
+            <p:ph type="body" idx="1"/>
+          </p:nvPr>
+        </p:nvSpPr>
+        <p:spPr/>
+        <p:txBody>
+          <a:bodyPr>
+            <a:normAutofit lnSpcReduction="10000"/>
+          </a:bodyPr>
+          <a:lstStyle/>
+          <a:p>
+            <a:r>
+              <a:rPr lang="en-US" dirty="0"/>
+              <a:t>Input domain: all possible inputs to a program</a:t>
+            </a:r>
+          </a:p>
+          <a:p>
+            <a:pPr lvl="1"/>
+            <a:r>
+              <a:rPr lang="en-US" dirty="0"/>
+              <a:t>Most input domains are so large that they are effectively infinite</a:t>
+            </a:r>
+          </a:p>
+          <a:p>
+            <a:r>
+              <a:rPr lang="en-US" dirty="0"/>
+              <a:t>Input parameters define the scope of the input domain</a:t>
+            </a:r>
+          </a:p>
+          <a:p>
+            <a:pPr lvl="1"/>
+            <a:r>
+              <a:rPr lang="en-US" dirty="0"/>
+              <a:t>Parameter values to a method</a:t>
+            </a:r>
+          </a:p>
+          <a:p>
+            <a:pPr lvl="1"/>
+            <a:r>
+              <a:rPr lang="en-US" dirty="0"/>
+              <a:t>Data from a file</a:t>
+            </a:r>
+          </a:p>
+          <a:p>
+            <a:pPr lvl="1"/>
+            <a:r>
+              <a:rPr lang="en-US" dirty="0"/>
+              <a:t>Global variables</a:t>
+            </a:r>
+          </a:p>
+          <a:p>
+            <a:pPr lvl="1"/>
+            <a:r>
+              <a:rPr lang="en-US" dirty="0"/>
+              <a:t>User inputs</a:t>
+            </a:r>
+          </a:p>
+          <a:p>
+            <a:r>
+              <a:rPr lang="en-US" dirty="0"/>
+              <a:t>We partition input domains into regions (called blocks)</a:t>
+            </a:r>
+          </a:p>
+          <a:p>
+            <a:r>
+              <a:rPr lang="en-US" dirty="0"/>
+              <a:t>Choose at least one value from each block</a:t>
+            </a:r>
+          </a:p>
+          <a:p>
+            <a:pPr lvl="1"/>
+            <a:r>
+              <a:rPr lang="en-US" dirty="0"/>
+              <a:t>Input domain:  Alphabetic letters</a:t>
+            </a:r>
+          </a:p>
+          <a:p>
+            <a:pPr lvl="1"/>
+            <a:r>
+              <a:rPr lang="en-US" dirty="0"/>
+              <a:t>Partitioning characteristic: Case of letter</a:t>
+            </a:r>
+          </a:p>
+          <a:p>
+            <a:pPr lvl="2"/>
+            <a:r>
+              <a:rPr lang="en-US" dirty="0"/>
+              <a:t>Block 1: upper case</a:t>
+            </a:r>
+          </a:p>
+          <a:p>
+            <a:pPr lvl="2"/>
+            <a:r>
+              <a:rPr lang="en-US" dirty="0"/>
+              <a:t>Block 2: lower case</a:t>
+            </a:r>
+          </a:p>
+          <a:p>
+            <a:pPr lvl="1"/>
+            <a:endParaRPr lang="en-US" dirty="0"/>
+          </a:p>
+          <a:p>
+            <a:endParaRPr lang="en-US" dirty="0"/>
+          </a:p>
+        </p:txBody>
+      </p:sp>
+    </p:spTree>
+    <p:extLst>
+      <p:ext uri="{BB962C8B-B14F-4D97-AF65-F5344CB8AC3E}">
+        <p14:creationId xmlns:p14="http://schemas.microsoft.com/office/powerpoint/2010/main" val="1627669416"/>
+      </p:ext>
+    </p:extLst>
+  </p:cSld>
+  <p:clrMapOvr>
+    <a:masterClrMapping/>
+  </p:clrMapOvr>
+</p:sld>
+</file>
+
+<file path=ppt/slides/slide26.xml><?xml version="1.0" encoding="utf-8"?>
+<p:sld xmlns:a="http://schemas.openxmlformats.org/drawingml/2006/main" xmlns:r="http://schemas.openxmlformats.org/officeDocument/2006/relationships" xmlns:p="http://schemas.openxmlformats.org/presentationml/2006/main">
+  <p:cSld>
+    <p:spTree>
+      <p:nvGrpSpPr>
+        <p:cNvPr id="1" name=""/>
+        <p:cNvGrpSpPr/>
+        <p:nvPr/>
+      </p:nvGrpSpPr>
+      <p:grpSpPr>
+        <a:xfrm>
+          <a:off x="0" y="0"/>
+          <a:ext cx="0" cy="0"/>
+          <a:chOff x="0" y="0"/>
+          <a:chExt cx="0" cy="0"/>
+        </a:xfrm>
+      </p:grpSpPr>
+      <p:sp>
+        <p:nvSpPr>
+          <p:cNvPr id="2" name="Title 1">
+            <a:extLst>
+              <a:ext uri="{FF2B5EF4-FFF2-40B4-BE49-F238E27FC236}">
+                <a16:creationId xmlns:a16="http://schemas.microsoft.com/office/drawing/2014/main" id="{00B6C14F-655D-7EDA-9961-DF6F9ECE33B2}"/>
+              </a:ext>
+            </a:extLst>
+          </p:cNvPr>
+          <p:cNvSpPr>
+            <a:spLocks noGrp="1"/>
+          </p:cNvSpPr>
+          <p:nvPr>
+            <p:ph type="title"/>
+          </p:nvPr>
+        </p:nvSpPr>
+        <p:spPr/>
+        <p:txBody>
+          <a:bodyPr>
+            <a:normAutofit fontScale="90000"/>
+          </a:bodyPr>
+          <a:lstStyle/>
+          <a:p>
+            <a:r>
+              <a:rPr lang="en-US" dirty="0"/>
+              <a:t>Partitioning Domain</a:t>
+            </a:r>
+          </a:p>
+        </p:txBody>
+      </p:sp>
+      <p:sp>
+        <p:nvSpPr>
+          <p:cNvPr id="3" name="Text Placeholder 2">
+            <a:extLst>
+              <a:ext uri="{FF2B5EF4-FFF2-40B4-BE49-F238E27FC236}">
+                <a16:creationId xmlns:a16="http://schemas.microsoft.com/office/drawing/2014/main" id="{B46AB4C2-648A-DA17-931B-7ADEB3BFFFFD}"/>
+              </a:ext>
+            </a:extLst>
+          </p:cNvPr>
+          <p:cNvSpPr>
+            <a:spLocks noGrp="1"/>
+          </p:cNvSpPr>
+          <p:nvPr>
+            <p:ph type="body" idx="1"/>
+          </p:nvPr>
+        </p:nvSpPr>
+        <p:spPr/>
+        <p:txBody>
+          <a:bodyPr/>
+          <a:lstStyle/>
+          <a:p>
+            <a:r>
+              <a:rPr lang="en-US" dirty="0"/>
+              <a:t>Domain D</a:t>
+            </a:r>
+          </a:p>
+          <a:p>
+            <a:r>
+              <a:rPr lang="en-US" dirty="0"/>
+              <a:t>Partition D into a set of blocks</a:t>
+            </a:r>
+          </a:p>
+          <a:p>
+            <a:r>
+              <a:rPr lang="en-US" dirty="0"/>
+              <a:t>For any two blocks b1 and b2, b1∩b2=</a:t>
+            </a:r>
+            <a:r>
+              <a:rPr kumimoji="1" lang="en-US" altLang="zh-CN" sz="2400" dirty="0">
+                <a:solidFill>
+                  <a:schemeClr val="bg2"/>
+                </a:solidFill>
+                <a:ea typeface="楷体_GB2312" pitchFamily="49" charset="-122"/>
+                <a:sym typeface="Symbol" pitchFamily="18" charset="2"/>
+              </a:rPr>
+              <a:t></a:t>
+            </a:r>
+            <a:endParaRPr lang="en-US" dirty="0"/>
+          </a:p>
+          <a:p>
+            <a:r>
+              <a:rPr lang="en-US" dirty="0"/>
+              <a:t>Together the blocks cover the domain D (complete)</a:t>
+            </a:r>
+          </a:p>
+          <a:p>
+            <a:endParaRPr lang="en-US" dirty="0"/>
+          </a:p>
+        </p:txBody>
+      </p:sp>
+    </p:spTree>
+    <p:extLst>
+      <p:ext uri="{BB962C8B-B14F-4D97-AF65-F5344CB8AC3E}">
+        <p14:creationId xmlns:p14="http://schemas.microsoft.com/office/powerpoint/2010/main" val="1067199745"/>
+      </p:ext>
+    </p:extLst>
+  </p:cSld>
+  <p:clrMapOvr>
+    <a:masterClrMapping/>
+  </p:clrMapOvr>
+</p:sld>
+</file>
+
+<file path=ppt/slides/slide27.xml><?xml version="1.0" encoding="utf-8"?>
+<p:sld xmlns:a="http://schemas.openxmlformats.org/drawingml/2006/main" xmlns:r="http://schemas.openxmlformats.org/officeDocument/2006/relationships" xmlns:p="http://schemas.openxmlformats.org/presentationml/2006/main">
+  <p:cSld>
+    <p:spTree>
+      <p:nvGrpSpPr>
+        <p:cNvPr id="1" name=""/>
+        <p:cNvGrpSpPr/>
+        <p:nvPr/>
+      </p:nvGrpSpPr>
+      <p:grpSpPr>
+        <a:xfrm>
+          <a:off x="0" y="0"/>
+          <a:ext cx="0" cy="0"/>
+          <a:chOff x="0" y="0"/>
+          <a:chExt cx="0" cy="0"/>
+        </a:xfrm>
+      </p:grpSpPr>
+      <p:sp>
+        <p:nvSpPr>
+          <p:cNvPr id="2" name="Title 1">
+            <a:extLst>
+              <a:ext uri="{FF2B5EF4-FFF2-40B4-BE49-F238E27FC236}">
+                <a16:creationId xmlns:a16="http://schemas.microsoft.com/office/drawing/2014/main" id="{049585A9-B227-B8BD-A955-17F767487CE4}"/>
+              </a:ext>
+            </a:extLst>
+          </p:cNvPr>
+          <p:cNvSpPr>
+            <a:spLocks noGrp="1"/>
+          </p:cNvSpPr>
+          <p:nvPr>
+            <p:ph type="title"/>
+          </p:nvPr>
+        </p:nvSpPr>
+        <p:spPr/>
+        <p:txBody>
+          <a:bodyPr>
+            <a:normAutofit fontScale="90000"/>
+          </a:bodyPr>
+          <a:lstStyle/>
+          <a:p>
+            <a:r>
+              <a:rPr lang="en-US" dirty="0"/>
+              <a:t>What is a characteristic?</a:t>
+            </a:r>
+          </a:p>
+        </p:txBody>
+      </p:sp>
+      <p:sp>
+        <p:nvSpPr>
+          <p:cNvPr id="3" name="Text Placeholder 2">
+            <a:extLst>
+              <a:ext uri="{FF2B5EF4-FFF2-40B4-BE49-F238E27FC236}">
+                <a16:creationId xmlns:a16="http://schemas.microsoft.com/office/drawing/2014/main" id="{29FD4C20-B9FA-6632-D0C8-5FAC479251DD}"/>
+              </a:ext>
+            </a:extLst>
+          </p:cNvPr>
+          <p:cNvSpPr>
+            <a:spLocks noGrp="1"/>
+          </p:cNvSpPr>
+          <p:nvPr>
+            <p:ph type="body" idx="1"/>
+          </p:nvPr>
+        </p:nvSpPr>
+        <p:spPr/>
+        <p:txBody>
+          <a:bodyPr>
+            <a:normAutofit/>
+          </a:bodyPr>
+          <a:lstStyle/>
+          <a:p>
+            <a:r>
+              <a:rPr lang="en-US" dirty="0"/>
+              <a:t>“A feature or quality belonging typically to a person, place, or thing and serving to identify it.”</a:t>
+            </a:r>
+          </a:p>
+          <a:p>
+            <a:r>
+              <a:rPr lang="en-US" dirty="0"/>
+              <a:t>Input: people</a:t>
+            </a:r>
+          </a:p>
+          <a:p>
+            <a:r>
+              <a:rPr lang="en-US" dirty="0"/>
+              <a:t>Characteristics: hair color, major</a:t>
+            </a:r>
+          </a:p>
+          <a:p>
+            <a:r>
+              <a:rPr lang="en-US" dirty="0"/>
+              <a:t>Blocks:</a:t>
+            </a:r>
+          </a:p>
+          <a:p>
+            <a:r>
+              <a:rPr lang="en-US" dirty="0"/>
+              <a:t>   A=(red, black, brown, blonde, other)</a:t>
+            </a:r>
+          </a:p>
+          <a:p>
+            <a:r>
+              <a:rPr lang="en-US" dirty="0"/>
+              <a:t>   B=(cs, </a:t>
+            </a:r>
+            <a:r>
+              <a:rPr lang="en-US" dirty="0" err="1"/>
+              <a:t>swe</a:t>
+            </a:r>
+            <a:r>
+              <a:rPr lang="en-US" dirty="0"/>
+              <a:t>, </a:t>
+            </a:r>
+            <a:r>
+              <a:rPr lang="en-US" dirty="0" err="1"/>
+              <a:t>ce</a:t>
+            </a:r>
+            <a:r>
+              <a:rPr lang="en-US" dirty="0"/>
+              <a:t>, math, </a:t>
+            </a:r>
+            <a:r>
+              <a:rPr lang="en-US" dirty="0" err="1"/>
+              <a:t>ist</a:t>
+            </a:r>
+            <a:r>
+              <a:rPr lang="en-US" dirty="0"/>
+              <a:t>, other)</a:t>
+            </a:r>
+          </a:p>
+          <a:p>
+            <a:r>
+              <a:rPr lang="en-US" dirty="0"/>
+              <a:t>Abstraction:</a:t>
+            </a:r>
+          </a:p>
+          <a:p>
+            <a:r>
+              <a:rPr lang="en-US" dirty="0"/>
+              <a:t>   A = [ a1, a2, a3, a4, a5 ]</a:t>
+            </a:r>
+          </a:p>
+          <a:p>
+            <a:r>
+              <a:rPr lang="en-US" dirty="0"/>
+              <a:t>   B = [ b1, b2, b3, b4, b5, b6 ]</a:t>
+            </a:r>
+          </a:p>
+        </p:txBody>
+      </p:sp>
+    </p:spTree>
+    <p:extLst>
+      <p:ext uri="{BB962C8B-B14F-4D97-AF65-F5344CB8AC3E}">
+        <p14:creationId xmlns:p14="http://schemas.microsoft.com/office/powerpoint/2010/main" val="2104879864"/>
+      </p:ext>
+    </p:extLst>
+  </p:cSld>
+  <p:clrMapOvr>
+    <a:masterClrMapping/>
+  </p:clrMapOvr>
+</p:sld>
+</file>
+
+<file path=ppt/slides/slide28.xml><?xml version="1.0" encoding="utf-8"?>
+<p:sld xmlns:a="http://schemas.openxmlformats.org/drawingml/2006/main" xmlns:r="http://schemas.openxmlformats.org/officeDocument/2006/relationships" xmlns:p="http://schemas.openxmlformats.org/presentationml/2006/main">
+  <p:cSld>
+    <p:spTree>
+      <p:nvGrpSpPr>
+        <p:cNvPr id="1" name=""/>
+        <p:cNvGrpSpPr/>
+        <p:nvPr/>
+      </p:nvGrpSpPr>
+      <p:grpSpPr>
+        <a:xfrm>
+          <a:off x="0" y="0"/>
+          <a:ext cx="0" cy="0"/>
+          <a:chOff x="0" y="0"/>
+          <a:chExt cx="0" cy="0"/>
+        </a:xfrm>
+      </p:grpSpPr>
+      <p:sp>
+        <p:nvSpPr>
+          <p:cNvPr id="2" name="Title 1">
+            <a:extLst>
+              <a:ext uri="{FF2B5EF4-FFF2-40B4-BE49-F238E27FC236}">
+                <a16:creationId xmlns:a16="http://schemas.microsoft.com/office/drawing/2014/main" id="{CE991BE8-B2DE-3642-FC03-08F70286AB79}"/>
+              </a:ext>
+            </a:extLst>
+          </p:cNvPr>
+          <p:cNvSpPr>
+            <a:spLocks noGrp="1"/>
+          </p:cNvSpPr>
+          <p:nvPr>
+            <p:ph type="title"/>
+          </p:nvPr>
+        </p:nvSpPr>
+        <p:spPr/>
+        <p:txBody>
+          <a:bodyPr>
+            <a:normAutofit fontScale="90000"/>
+          </a:bodyPr>
+          <a:lstStyle/>
+          <a:p>
+            <a:r>
+              <a:rPr lang="en-US" dirty="0"/>
+              <a:t>Modeling the input domain (IDM)</a:t>
+            </a:r>
+          </a:p>
+        </p:txBody>
+      </p:sp>
+      <p:sp>
+        <p:nvSpPr>
+          <p:cNvPr id="3" name="Text Placeholder 2">
+            <a:extLst>
+              <a:ext uri="{FF2B5EF4-FFF2-40B4-BE49-F238E27FC236}">
+                <a16:creationId xmlns:a16="http://schemas.microsoft.com/office/drawing/2014/main" id="{AC305643-3A78-0E84-A429-584F5F73464D}"/>
+              </a:ext>
+            </a:extLst>
+          </p:cNvPr>
+          <p:cNvSpPr>
+            <a:spLocks noGrp="1"/>
+          </p:cNvSpPr>
+          <p:nvPr>
+            <p:ph type="body" idx="1"/>
+          </p:nvPr>
+        </p:nvSpPr>
+        <p:spPr/>
+        <p:txBody>
+          <a:bodyPr/>
+          <a:lstStyle/>
+          <a:p>
+            <a:r>
+              <a:rPr lang="en-US" dirty="0"/>
+              <a:t>Step 1 : Identify testable functions</a:t>
+            </a:r>
+          </a:p>
+          <a:p>
+            <a:endParaRPr lang="en-US" dirty="0"/>
+          </a:p>
+          <a:p>
+            <a:r>
+              <a:rPr lang="en-US" dirty="0"/>
+              <a:t>Step 2 : Find all inputs, parameters, &amp; characteristics</a:t>
+            </a:r>
+          </a:p>
+          <a:p>
+            <a:endParaRPr lang="en-US" dirty="0"/>
+          </a:p>
+          <a:p>
+            <a:r>
+              <a:rPr lang="en-US" dirty="0"/>
+              <a:t>Step 3 : Model the input domain</a:t>
+            </a:r>
+          </a:p>
+          <a:p>
+            <a:endParaRPr lang="en-US" dirty="0"/>
+          </a:p>
+          <a:p>
+            <a:r>
+              <a:rPr lang="en-US" dirty="0"/>
+              <a:t>Step 4 : Apply a test criterion to choose combinations of values</a:t>
+            </a:r>
+          </a:p>
+          <a:p>
+            <a:endParaRPr lang="en-US" dirty="0"/>
+          </a:p>
+          <a:p>
+            <a:r>
+              <a:rPr lang="en-US" dirty="0"/>
+              <a:t>Step 5 : Refine combinations of blocks into test inputs</a:t>
+            </a:r>
+          </a:p>
+          <a:p>
+            <a:endParaRPr lang="en-US" dirty="0"/>
+          </a:p>
+        </p:txBody>
+      </p:sp>
+    </p:spTree>
+    <p:extLst>
+      <p:ext uri="{BB962C8B-B14F-4D97-AF65-F5344CB8AC3E}">
+        <p14:creationId xmlns:p14="http://schemas.microsoft.com/office/powerpoint/2010/main" val="2217799822"/>
+      </p:ext>
+    </p:extLst>
+  </p:cSld>
+  <p:clrMapOvr>
+    <a:masterClrMapping/>
+  </p:clrMapOvr>
+</p:sld>
+</file>
+
+<file path=ppt/slides/slide29.xml><?xml version="1.0" encoding="utf-8"?>
+<p:sld xmlns:a="http://schemas.openxmlformats.org/drawingml/2006/main" xmlns:r="http://schemas.openxmlformats.org/officeDocument/2006/relationships" xmlns:p="http://schemas.openxmlformats.org/presentationml/2006/main">
+  <p:cSld>
+    <p:spTree>
+      <p:nvGrpSpPr>
+        <p:cNvPr id="1" name=""/>
+        <p:cNvGrpSpPr/>
+        <p:nvPr/>
+      </p:nvGrpSpPr>
+      <p:grpSpPr>
+        <a:xfrm>
+          <a:off x="0" y="0"/>
+          <a:ext cx="0" cy="0"/>
+          <a:chOff x="0" y="0"/>
+          <a:chExt cx="0" cy="0"/>
+        </a:xfrm>
+      </p:grpSpPr>
+      <p:sp>
+        <p:nvSpPr>
+          <p:cNvPr id="2" name="Title 1">
+            <a:extLst>
+              <a:ext uri="{FF2B5EF4-FFF2-40B4-BE49-F238E27FC236}">
+                <a16:creationId xmlns:a16="http://schemas.microsoft.com/office/drawing/2014/main" id="{CAC5B7E9-215E-646D-D1B9-A55671352C7D}"/>
+              </a:ext>
+            </a:extLst>
+          </p:cNvPr>
+          <p:cNvSpPr>
+            <a:spLocks noGrp="1"/>
+          </p:cNvSpPr>
+          <p:nvPr>
+            <p:ph type="title"/>
+          </p:nvPr>
+        </p:nvSpPr>
+        <p:spPr/>
+        <p:txBody>
+          <a:bodyPr>
+            <a:normAutofit fontScale="90000"/>
+          </a:bodyPr>
+          <a:lstStyle/>
+          <a:p>
+            <a:r>
+              <a:rPr lang="en-US" dirty="0"/>
+              <a:t>IDM Hints</a:t>
+            </a:r>
+          </a:p>
+        </p:txBody>
+      </p:sp>
+      <p:sp>
+        <p:nvSpPr>
+          <p:cNvPr id="3" name="Text Placeholder 2">
+            <a:extLst>
+              <a:ext uri="{FF2B5EF4-FFF2-40B4-BE49-F238E27FC236}">
+                <a16:creationId xmlns:a16="http://schemas.microsoft.com/office/drawing/2014/main" id="{98BD7BFC-CB84-8C17-1812-69631F533842}"/>
+              </a:ext>
+            </a:extLst>
+          </p:cNvPr>
+          <p:cNvSpPr>
+            <a:spLocks noGrp="1"/>
+          </p:cNvSpPr>
+          <p:nvPr>
+            <p:ph type="body" idx="1"/>
+          </p:nvPr>
+        </p:nvSpPr>
+        <p:spPr/>
+        <p:txBody>
+          <a:bodyPr/>
+          <a:lstStyle/>
+          <a:p>
+            <a:r>
+              <a:rPr lang="en-US" dirty="0"/>
+              <a:t>More characteristics -&gt; more tests</a:t>
+            </a:r>
+          </a:p>
+          <a:p>
+            <a:r>
+              <a:rPr lang="en-US" dirty="0"/>
+              <a:t>More blocks -&gt; more tests</a:t>
+            </a:r>
+          </a:p>
+          <a:p>
+            <a:r>
+              <a:rPr lang="en-US" dirty="0"/>
+              <a:t>Do not use program source</a:t>
+            </a:r>
+          </a:p>
+          <a:p>
+            <a:r>
+              <a:rPr lang="en-US" dirty="0"/>
+              <a:t>Choose values strategically</a:t>
+            </a:r>
+          </a:p>
+          <a:p>
+            <a:pPr lvl="1"/>
+            <a:r>
+              <a:rPr lang="en-US" dirty="0"/>
+              <a:t>Valid, invalid, special values</a:t>
+            </a:r>
+          </a:p>
+          <a:p>
+            <a:pPr lvl="1"/>
+            <a:r>
+              <a:rPr lang="en-US" dirty="0"/>
+              <a:t>Explore boundaries</a:t>
+            </a:r>
+          </a:p>
+          <a:p>
+            <a:pPr lvl="1"/>
+            <a:r>
+              <a:rPr lang="en-US" dirty="0"/>
+              <a:t>Balance the number of blocks in the characteristics</a:t>
+            </a:r>
+          </a:p>
+        </p:txBody>
+      </p:sp>
+    </p:spTree>
+    <p:extLst>
+      <p:ext uri="{BB962C8B-B14F-4D97-AF65-F5344CB8AC3E}">
+        <p14:creationId xmlns:p14="http://schemas.microsoft.com/office/powerpoint/2010/main" val="2137749077"/>
       </p:ext>
     </p:extLst>
   </p:cSld>
@@ -10701,7 +11570,7 @@
         </p:spPr>
         <p:txBody>
           <a:bodyPr spcFirstLastPara="1" wrap="square" lIns="91425" tIns="91425" rIns="91425" bIns="91425" anchor="t" anchorCtr="0">
-            <a:normAutofit fontScale="92500"/>
+            <a:normAutofit fontScale="92500" lnSpcReduction="10000"/>
           </a:bodyPr>
           <a:lstStyle/>
           <a:p>
@@ -11099,6 +11968,1627 @@
         </p:txBody>
       </p:sp>
     </p:spTree>
+  </p:cSld>
+  <p:clrMapOvr>
+    <a:masterClrMapping/>
+  </p:clrMapOvr>
+</p:sld>
+</file>
+
+<file path=ppt/slides/slide30.xml><?xml version="1.0" encoding="utf-8"?>
+<p:sld xmlns:a="http://schemas.openxmlformats.org/drawingml/2006/main" xmlns:r="http://schemas.openxmlformats.org/officeDocument/2006/relationships" xmlns:p="http://schemas.openxmlformats.org/presentationml/2006/main">
+  <p:cSld>
+    <p:spTree>
+      <p:nvGrpSpPr>
+        <p:cNvPr id="1" name=""/>
+        <p:cNvGrpSpPr/>
+        <p:nvPr/>
+      </p:nvGrpSpPr>
+      <p:grpSpPr>
+        <a:xfrm>
+          <a:off x="0" y="0"/>
+          <a:ext cx="0" cy="0"/>
+          <a:chOff x="0" y="0"/>
+          <a:chExt cx="0" cy="0"/>
+        </a:xfrm>
+      </p:grpSpPr>
+      <p:sp>
+        <p:nvSpPr>
+          <p:cNvPr id="2" name="Title 1">
+            <a:extLst>
+              <a:ext uri="{FF2B5EF4-FFF2-40B4-BE49-F238E27FC236}">
+                <a16:creationId xmlns:a16="http://schemas.microsoft.com/office/drawing/2014/main" id="{1C123EBC-320F-5EE2-7532-E3EB229EFE50}"/>
+              </a:ext>
+            </a:extLst>
+          </p:cNvPr>
+          <p:cNvSpPr>
+            <a:spLocks noGrp="1"/>
+          </p:cNvSpPr>
+          <p:nvPr>
+            <p:ph type="title"/>
+          </p:nvPr>
+        </p:nvSpPr>
+        <p:spPr/>
+        <p:txBody>
+          <a:bodyPr>
+            <a:normAutofit fontScale="90000"/>
+          </a:bodyPr>
+          <a:lstStyle/>
+          <a:p>
+            <a:r>
+              <a:rPr lang="en-US" dirty="0"/>
+              <a:t>An Example</a:t>
+            </a:r>
+          </a:p>
+        </p:txBody>
+      </p:sp>
+      <p:sp>
+        <p:nvSpPr>
+          <p:cNvPr id="3" name="Text Placeholder 2">
+            <a:extLst>
+              <a:ext uri="{FF2B5EF4-FFF2-40B4-BE49-F238E27FC236}">
+                <a16:creationId xmlns:a16="http://schemas.microsoft.com/office/drawing/2014/main" id="{AC47C23F-6A17-3531-B521-645E79F2E454}"/>
+              </a:ext>
+            </a:extLst>
+          </p:cNvPr>
+          <p:cNvSpPr>
+            <a:spLocks noGrp="1"/>
+          </p:cNvSpPr>
+          <p:nvPr>
+            <p:ph type="body" idx="1"/>
+          </p:nvPr>
+        </p:nvSpPr>
+        <p:spPr/>
+        <p:txBody>
+          <a:bodyPr/>
+          <a:lstStyle/>
+          <a:p>
+            <a:r>
+              <a:rPr lang="en-US" altLang="en-US" dirty="0"/>
+              <a:t>After partitioning characteristics into blocks, testers design tests by combining blocks from different characteristics</a:t>
+            </a:r>
+          </a:p>
+          <a:p>
+            <a:pPr lvl="1"/>
+            <a:r>
+              <a:rPr lang="en-US" altLang="en-US" dirty="0"/>
+              <a:t>3 Characteristics (abstract): A, B, C</a:t>
+            </a:r>
+          </a:p>
+          <a:p>
+            <a:pPr lvl="1"/>
+            <a:r>
+              <a:rPr lang="en-US" altLang="en-US" dirty="0"/>
+              <a:t>Abstract blocks: A = [a1, a2, a3,a4]; B = [b1, b2]; C = [c1, c2,c3]</a:t>
+            </a:r>
+          </a:p>
+          <a:p>
+            <a:r>
+              <a:rPr lang="en-US" altLang="en-US" dirty="0"/>
+              <a:t>A test starts by combining one block from each characteristic</a:t>
+            </a:r>
+          </a:p>
+          <a:p>
+            <a:pPr lvl="1"/>
+            <a:r>
+              <a:rPr lang="en-US" altLang="en-US" dirty="0"/>
+              <a:t>Then values are chosen to satisfy the combinations</a:t>
+            </a:r>
+          </a:p>
+          <a:p>
+            <a:r>
+              <a:rPr lang="en-US" altLang="en-US" dirty="0"/>
+              <a:t>We use criteria to choose effective combinations</a:t>
+            </a:r>
+            <a:endParaRPr lang="en-US" dirty="0"/>
+          </a:p>
+        </p:txBody>
+      </p:sp>
+    </p:spTree>
+    <p:extLst>
+      <p:ext uri="{BB962C8B-B14F-4D97-AF65-F5344CB8AC3E}">
+        <p14:creationId xmlns:p14="http://schemas.microsoft.com/office/powerpoint/2010/main" val="3039554566"/>
+      </p:ext>
+    </p:extLst>
+  </p:cSld>
+  <p:clrMapOvr>
+    <a:masterClrMapping/>
+  </p:clrMapOvr>
+</p:sld>
+</file>
+
+<file path=ppt/slides/slide31.xml><?xml version="1.0" encoding="utf-8"?>
+<p:sld xmlns:a="http://schemas.openxmlformats.org/drawingml/2006/main" xmlns:r="http://schemas.openxmlformats.org/officeDocument/2006/relationships" xmlns:p="http://schemas.openxmlformats.org/presentationml/2006/main">
+  <p:cSld>
+    <p:spTree>
+      <p:nvGrpSpPr>
+        <p:cNvPr id="1" name=""/>
+        <p:cNvGrpSpPr/>
+        <p:nvPr/>
+      </p:nvGrpSpPr>
+      <p:grpSpPr>
+        <a:xfrm>
+          <a:off x="0" y="0"/>
+          <a:ext cx="0" cy="0"/>
+          <a:chOff x="0" y="0"/>
+          <a:chExt cx="0" cy="0"/>
+        </a:xfrm>
+      </p:grpSpPr>
+      <p:sp>
+        <p:nvSpPr>
+          <p:cNvPr id="2" name="Title 1">
+            <a:extLst>
+              <a:ext uri="{FF2B5EF4-FFF2-40B4-BE49-F238E27FC236}">
+                <a16:creationId xmlns:a16="http://schemas.microsoft.com/office/drawing/2014/main" id="{76928135-2B97-8043-214D-D3A987B6CB07}"/>
+              </a:ext>
+            </a:extLst>
+          </p:cNvPr>
+          <p:cNvSpPr>
+            <a:spLocks noGrp="1"/>
+          </p:cNvSpPr>
+          <p:nvPr>
+            <p:ph type="title"/>
+          </p:nvPr>
+        </p:nvSpPr>
+        <p:spPr/>
+        <p:txBody>
+          <a:bodyPr>
+            <a:normAutofit fontScale="90000"/>
+          </a:bodyPr>
+          <a:lstStyle/>
+          <a:p>
+            <a:r>
+              <a:rPr lang="en-US" dirty="0"/>
+              <a:t>All combinations criterion (</a:t>
+            </a:r>
+            <a:r>
+              <a:rPr lang="en-US" dirty="0" err="1"/>
+              <a:t>ACoC</a:t>
+            </a:r>
+            <a:r>
+              <a:rPr lang="en-US" dirty="0"/>
+              <a:t>)</a:t>
+            </a:r>
+          </a:p>
+        </p:txBody>
+      </p:sp>
+      <p:sp>
+        <p:nvSpPr>
+          <p:cNvPr id="3" name="Text Placeholder 2">
+            <a:extLst>
+              <a:ext uri="{FF2B5EF4-FFF2-40B4-BE49-F238E27FC236}">
+                <a16:creationId xmlns:a16="http://schemas.microsoft.com/office/drawing/2014/main" id="{B050979A-B25B-FAE9-89A5-3E10ED6CE560}"/>
+              </a:ext>
+            </a:extLst>
+          </p:cNvPr>
+          <p:cNvSpPr>
+            <a:spLocks noGrp="1"/>
+          </p:cNvSpPr>
+          <p:nvPr>
+            <p:ph type="body" idx="1"/>
+          </p:nvPr>
+        </p:nvSpPr>
+        <p:spPr/>
+        <p:txBody>
+          <a:bodyPr/>
+          <a:lstStyle/>
+          <a:p>
+            <a:endParaRPr lang="en-US" dirty="0"/>
+          </a:p>
+        </p:txBody>
+      </p:sp>
+      <p:sp>
+        <p:nvSpPr>
+          <p:cNvPr id="4" name="Content Placeholder 2">
+            <a:extLst>
+              <a:ext uri="{FF2B5EF4-FFF2-40B4-BE49-F238E27FC236}">
+                <a16:creationId xmlns:a16="http://schemas.microsoft.com/office/drawing/2014/main" id="{C106FE08-2F83-0BA0-2A2A-A5015C8F8BED}"/>
+              </a:ext>
+            </a:extLst>
+          </p:cNvPr>
+          <p:cNvSpPr>
+            <a:spLocks noGrp="1"/>
+          </p:cNvSpPr>
+          <p:nvPr/>
+        </p:nvSpPr>
+        <p:spPr bwMode="auto">
+          <a:xfrm>
+            <a:off x="564630" y="1152475"/>
+            <a:ext cx="6493871" cy="1917499"/>
+          </a:xfrm>
+          <a:prstGeom prst="rect">
+            <a:avLst/>
+          </a:prstGeom>
+          <a:noFill/>
+          <a:ln>
+            <a:noFill/>
+          </a:ln>
+          <a:extLst>
+            <a:ext uri="{909E8E84-426E-40DD-AFC4-6F175D3DCCD1}">
+              <a14:hiddenFill xmlns:a14="http://schemas.microsoft.com/office/drawing/2010/main">
+                <a:solidFill>
+                  <a:srgbClr val="FFFFFF"/>
+                </a:solidFill>
+              </a14:hiddenFill>
+            </a:ext>
+            <a:ext uri="{91240B29-F687-4F45-9708-019B960494DF}">
+              <a14:hiddenLine xmlns:a14="http://schemas.microsoft.com/office/drawing/2010/main" w="9525">
+                <a:solidFill>
+                  <a:srgbClr val="000000"/>
+                </a:solidFill>
+                <a:miter lim="800000"/>
+                <a:headEnd/>
+                <a:tailEnd/>
+              </a14:hiddenLine>
+            </a:ext>
+          </a:extLst>
+        </p:spPr>
+        <p:txBody>
+          <a:bodyPr vert="horz" wrap="square" lIns="92075" tIns="46038" rIns="92075" bIns="46038" numCol="1" anchor="t" anchorCtr="0" compatLnSpc="1">
+            <a:prstTxWarp prst="textNoShape">
+              <a:avLst/>
+            </a:prstTxWarp>
+          </a:bodyPr>
+          <a:lstStyle>
+            <a:lvl1pPr marL="285750" indent="-285750" algn="l" rtl="0" eaLnBrk="0" fontAlgn="base" hangingPunct="0">
+              <a:lnSpc>
+                <a:spcPct val="90000"/>
+              </a:lnSpc>
+              <a:spcBef>
+                <a:spcPct val="30000"/>
+              </a:spcBef>
+              <a:spcAft>
+                <a:spcPct val="0"/>
+              </a:spcAft>
+              <a:buSzPct val="85000"/>
+              <a:buChar char="•"/>
+              <a:defRPr sz="2800" b="0">
+                <a:solidFill>
+                  <a:schemeClr val="tx1"/>
+                </a:solidFill>
+                <a:latin typeface="Gill Sans MT" panose="020B0502020104020203" pitchFamily="34" charset="0"/>
+                <a:ea typeface="+mn-ea"/>
+                <a:cs typeface="+mn-cs"/>
+              </a:defRPr>
+            </a:lvl1pPr>
+            <a:lvl2pPr marL="685800" indent="-228600" algn="l" rtl="0" eaLnBrk="0" fontAlgn="base" hangingPunct="0">
+              <a:lnSpc>
+                <a:spcPct val="90000"/>
+              </a:lnSpc>
+              <a:spcBef>
+                <a:spcPct val="30000"/>
+              </a:spcBef>
+              <a:spcAft>
+                <a:spcPct val="0"/>
+              </a:spcAft>
+              <a:buSzPct val="100000"/>
+              <a:buChar char="–"/>
+              <a:defRPr sz="2400" b="0">
+                <a:solidFill>
+                  <a:schemeClr val="tx1"/>
+                </a:solidFill>
+                <a:latin typeface="Gill Sans MT" panose="020B0502020104020203" pitchFamily="34" charset="0"/>
+              </a:defRPr>
+            </a:lvl2pPr>
+            <a:lvl3pPr marL="1143000" indent="-228600" algn="l" rtl="0" eaLnBrk="0" fontAlgn="base" hangingPunct="0">
+              <a:lnSpc>
+                <a:spcPct val="90000"/>
+              </a:lnSpc>
+              <a:spcBef>
+                <a:spcPct val="30000"/>
+              </a:spcBef>
+              <a:spcAft>
+                <a:spcPct val="0"/>
+              </a:spcAft>
+              <a:buSzPct val="100000"/>
+              <a:buChar char="•"/>
+              <a:defRPr sz="2000" b="0">
+                <a:solidFill>
+                  <a:schemeClr val="tx1"/>
+                </a:solidFill>
+                <a:latin typeface="Gill Sans MT" panose="020B0502020104020203" pitchFamily="34" charset="0"/>
+              </a:defRPr>
+            </a:lvl3pPr>
+            <a:lvl4pPr marL="1543050" indent="-171450" algn="l" rtl="0" eaLnBrk="0" fontAlgn="base" hangingPunct="0">
+              <a:lnSpc>
+                <a:spcPct val="90000"/>
+              </a:lnSpc>
+              <a:spcBef>
+                <a:spcPct val="30000"/>
+              </a:spcBef>
+              <a:spcAft>
+                <a:spcPct val="0"/>
+              </a:spcAft>
+              <a:buSzPct val="100000"/>
+              <a:buChar char="–"/>
+              <a:defRPr sz="2000" b="0">
+                <a:solidFill>
+                  <a:schemeClr val="tx1"/>
+                </a:solidFill>
+                <a:latin typeface="Gill Sans MT" panose="020B0502020104020203" pitchFamily="34" charset="0"/>
+              </a:defRPr>
+            </a:lvl4pPr>
+            <a:lvl5pPr marL="2000250" indent="-171450" algn="l" rtl="0" eaLnBrk="0" fontAlgn="base" hangingPunct="0">
+              <a:lnSpc>
+                <a:spcPct val="90000"/>
+              </a:lnSpc>
+              <a:spcBef>
+                <a:spcPct val="30000"/>
+              </a:spcBef>
+              <a:spcAft>
+                <a:spcPct val="0"/>
+              </a:spcAft>
+              <a:buSzPct val="100000"/>
+              <a:buFont typeface="Wingdings" pitchFamily="2" charset="2"/>
+              <a:buChar char="Ø"/>
+              <a:defRPr sz="2000" b="0">
+                <a:solidFill>
+                  <a:schemeClr val="tx1"/>
+                </a:solidFill>
+                <a:latin typeface="Gill Sans MT" panose="020B0502020104020203" pitchFamily="34" charset="0"/>
+              </a:defRPr>
+            </a:lvl5pPr>
+            <a:lvl6pPr marL="2457450" indent="-171450" algn="l" rtl="0" eaLnBrk="0" fontAlgn="base" hangingPunct="0">
+              <a:lnSpc>
+                <a:spcPct val="90000"/>
+              </a:lnSpc>
+              <a:spcBef>
+                <a:spcPct val="30000"/>
+              </a:spcBef>
+              <a:spcAft>
+                <a:spcPct val="0"/>
+              </a:spcAft>
+              <a:buSzPct val="100000"/>
+              <a:buFont typeface="Wingdings" pitchFamily="2" charset="2"/>
+              <a:buChar char="Ø"/>
+              <a:defRPr b="1">
+                <a:solidFill>
+                  <a:schemeClr val="tx1"/>
+                </a:solidFill>
+                <a:latin typeface="+mn-lt"/>
+              </a:defRPr>
+            </a:lvl6pPr>
+            <a:lvl7pPr marL="2914650" indent="-171450" algn="l" rtl="0" eaLnBrk="0" fontAlgn="base" hangingPunct="0">
+              <a:lnSpc>
+                <a:spcPct val="90000"/>
+              </a:lnSpc>
+              <a:spcBef>
+                <a:spcPct val="30000"/>
+              </a:spcBef>
+              <a:spcAft>
+                <a:spcPct val="0"/>
+              </a:spcAft>
+              <a:buSzPct val="100000"/>
+              <a:buFont typeface="Wingdings" pitchFamily="2" charset="2"/>
+              <a:buChar char="Ø"/>
+              <a:defRPr b="1">
+                <a:solidFill>
+                  <a:schemeClr val="tx1"/>
+                </a:solidFill>
+                <a:latin typeface="+mn-lt"/>
+              </a:defRPr>
+            </a:lvl7pPr>
+            <a:lvl8pPr marL="3371850" indent="-171450" algn="l" rtl="0" eaLnBrk="0" fontAlgn="base" hangingPunct="0">
+              <a:lnSpc>
+                <a:spcPct val="90000"/>
+              </a:lnSpc>
+              <a:spcBef>
+                <a:spcPct val="30000"/>
+              </a:spcBef>
+              <a:spcAft>
+                <a:spcPct val="0"/>
+              </a:spcAft>
+              <a:buSzPct val="100000"/>
+              <a:buFont typeface="Wingdings" pitchFamily="2" charset="2"/>
+              <a:buChar char="Ø"/>
+              <a:defRPr b="1">
+                <a:solidFill>
+                  <a:schemeClr val="tx1"/>
+                </a:solidFill>
+                <a:latin typeface="+mn-lt"/>
+              </a:defRPr>
+            </a:lvl8pPr>
+            <a:lvl9pPr marL="3829050" indent="-171450" algn="l" rtl="0" eaLnBrk="0" fontAlgn="base" hangingPunct="0">
+              <a:lnSpc>
+                <a:spcPct val="90000"/>
+              </a:lnSpc>
+              <a:spcBef>
+                <a:spcPct val="30000"/>
+              </a:spcBef>
+              <a:spcAft>
+                <a:spcPct val="0"/>
+              </a:spcAft>
+              <a:buSzPct val="100000"/>
+              <a:buFont typeface="Wingdings" pitchFamily="2" charset="2"/>
+              <a:buChar char="Ø"/>
+              <a:defRPr b="1">
+                <a:solidFill>
+                  <a:schemeClr val="tx1"/>
+                </a:solidFill>
+                <a:latin typeface="+mn-lt"/>
+              </a:defRPr>
+            </a:lvl9pPr>
+          </a:lstStyle>
+          <a:p>
+            <a:pPr marL="0" indent="0" algn="ctr">
+              <a:buNone/>
+            </a:pPr>
+            <a:r>
+              <a:rPr lang="en-US" altLang="en-US" dirty="0"/>
+              <a:t>The most obvious criterion is to choose all combinations</a:t>
+            </a:r>
+          </a:p>
+        </p:txBody>
+      </p:sp>
+      <p:pic>
+        <p:nvPicPr>
+          <p:cNvPr id="5" name="table">
+            <a:extLst>
+              <a:ext uri="{FF2B5EF4-FFF2-40B4-BE49-F238E27FC236}">
+                <a16:creationId xmlns:a16="http://schemas.microsoft.com/office/drawing/2014/main" id="{7907935D-AA45-B6DE-6808-86F5FBFE8DF5}"/>
+              </a:ext>
+            </a:extLst>
+          </p:cNvPr>
+          <p:cNvPicPr>
+            <a:picLocks noChangeAspect="1"/>
+          </p:cNvPicPr>
+          <p:nvPr/>
+        </p:nvPicPr>
+        <p:blipFill>
+          <a:blip r:embed="rId2"/>
+          <a:stretch>
+            <a:fillRect/>
+          </a:stretch>
+        </p:blipFill>
+        <p:spPr>
+          <a:xfrm>
+            <a:off x="2412576" y="2227274"/>
+            <a:ext cx="5000256" cy="1954900"/>
+          </a:xfrm>
+          <a:prstGeom prst="rect">
+            <a:avLst/>
+          </a:prstGeom>
+        </p:spPr>
+      </p:pic>
+    </p:spTree>
+    <p:extLst>
+      <p:ext uri="{BB962C8B-B14F-4D97-AF65-F5344CB8AC3E}">
+        <p14:creationId xmlns:p14="http://schemas.microsoft.com/office/powerpoint/2010/main" val="3949891490"/>
+      </p:ext>
+    </p:extLst>
+  </p:cSld>
+  <p:clrMapOvr>
+    <a:masterClrMapping/>
+  </p:clrMapOvr>
+</p:sld>
+</file>
+
+<file path=ppt/slides/slide32.xml><?xml version="1.0" encoding="utf-8"?>
+<p:sld xmlns:a="http://schemas.openxmlformats.org/drawingml/2006/main" xmlns:r="http://schemas.openxmlformats.org/officeDocument/2006/relationships" xmlns:p="http://schemas.openxmlformats.org/presentationml/2006/main">
+  <p:cSld>
+    <p:spTree>
+      <p:nvGrpSpPr>
+        <p:cNvPr id="1" name=""/>
+        <p:cNvGrpSpPr/>
+        <p:nvPr/>
+      </p:nvGrpSpPr>
+      <p:grpSpPr>
+        <a:xfrm>
+          <a:off x="0" y="0"/>
+          <a:ext cx="0" cy="0"/>
+          <a:chOff x="0" y="0"/>
+          <a:chExt cx="0" cy="0"/>
+        </a:xfrm>
+      </p:grpSpPr>
+      <p:sp>
+        <p:nvSpPr>
+          <p:cNvPr id="2" name="Title 1">
+            <a:extLst>
+              <a:ext uri="{FF2B5EF4-FFF2-40B4-BE49-F238E27FC236}">
+                <a16:creationId xmlns:a16="http://schemas.microsoft.com/office/drawing/2014/main" id="{F03C5313-41DE-2B7E-DC4B-506C785B1BDA}"/>
+              </a:ext>
+            </a:extLst>
+          </p:cNvPr>
+          <p:cNvSpPr>
+            <a:spLocks noGrp="1"/>
+          </p:cNvSpPr>
+          <p:nvPr>
+            <p:ph type="title"/>
+          </p:nvPr>
+        </p:nvSpPr>
+        <p:spPr/>
+        <p:txBody>
+          <a:bodyPr>
+            <a:normAutofit fontScale="90000"/>
+          </a:bodyPr>
+          <a:lstStyle/>
+          <a:p>
+            <a:r>
+              <a:rPr lang="en-US" dirty="0"/>
+              <a:t>Another Example</a:t>
+            </a:r>
+          </a:p>
+        </p:txBody>
+      </p:sp>
+      <p:sp>
+        <p:nvSpPr>
+          <p:cNvPr id="3" name="Text Placeholder 2">
+            <a:extLst>
+              <a:ext uri="{FF2B5EF4-FFF2-40B4-BE49-F238E27FC236}">
+                <a16:creationId xmlns:a16="http://schemas.microsoft.com/office/drawing/2014/main" id="{BFE2D678-48A7-B909-C1AB-7C889AC2A1D8}"/>
+              </a:ext>
+            </a:extLst>
+          </p:cNvPr>
+          <p:cNvSpPr>
+            <a:spLocks noGrp="1"/>
+          </p:cNvSpPr>
+          <p:nvPr>
+            <p:ph type="body" idx="1"/>
+          </p:nvPr>
+        </p:nvSpPr>
+        <p:spPr/>
+        <p:txBody>
+          <a:bodyPr/>
+          <a:lstStyle/>
+          <a:p>
+            <a:r>
+              <a:rPr lang="en-US" dirty="0"/>
+              <a:t>Input: students</a:t>
+            </a:r>
+          </a:p>
+          <a:p>
+            <a:r>
+              <a:rPr lang="en-US" dirty="0"/>
+              <a:t>Characteristics: Level, Mode, Major, Classification</a:t>
+            </a:r>
+          </a:p>
+          <a:p>
+            <a:r>
+              <a:rPr lang="en-US" dirty="0"/>
+              <a:t>Blocks:</a:t>
+            </a:r>
+          </a:p>
+          <a:p>
+            <a:pPr lvl="1"/>
+            <a:r>
+              <a:rPr lang="en-US" dirty="0"/>
+              <a:t>Level: ( grad, undergrad )</a:t>
+            </a:r>
+          </a:p>
+          <a:p>
+            <a:pPr lvl="1"/>
+            <a:r>
+              <a:rPr lang="en-US" dirty="0"/>
+              <a:t>Mode: ( full-time, part-time )</a:t>
+            </a:r>
+          </a:p>
+          <a:p>
+            <a:pPr lvl="1"/>
+            <a:r>
+              <a:rPr lang="en-US" dirty="0"/>
+              <a:t>Major: ( cs, </a:t>
+            </a:r>
+            <a:r>
+              <a:rPr lang="en-US" dirty="0" err="1"/>
+              <a:t>swe</a:t>
+            </a:r>
+            <a:r>
+              <a:rPr lang="en-US" dirty="0"/>
+              <a:t>, other )</a:t>
+            </a:r>
+          </a:p>
+          <a:p>
+            <a:pPr lvl="1"/>
+            <a:r>
+              <a:rPr lang="en-US" dirty="0"/>
+              <a:t>Classification: ( in-state, out-of-state )</a:t>
+            </a:r>
+          </a:p>
+          <a:p>
+            <a:r>
+              <a:rPr lang="en-US" dirty="0"/>
+              <a:t>Abstract IDM:</a:t>
+            </a:r>
+          </a:p>
+          <a:p>
+            <a:pPr lvl="1"/>
+            <a:r>
+              <a:rPr lang="en-US" dirty="0"/>
+              <a:t>   A = [ a1, a2 ]	C = [ c1, c2, c3 ]</a:t>
+            </a:r>
+          </a:p>
+          <a:p>
+            <a:pPr lvl="1"/>
+            <a:r>
+              <a:rPr lang="en-US" dirty="0"/>
+              <a:t>   B = [ b1, b2 ]	D = [ d1, d2 ]</a:t>
+            </a:r>
+          </a:p>
+          <a:p>
+            <a:endParaRPr lang="en-US" dirty="0"/>
+          </a:p>
+        </p:txBody>
+      </p:sp>
+      <p:sp>
+        <p:nvSpPr>
+          <p:cNvPr id="4" name="TextBox 3">
+            <a:extLst>
+              <a:ext uri="{FF2B5EF4-FFF2-40B4-BE49-F238E27FC236}">
+                <a16:creationId xmlns:a16="http://schemas.microsoft.com/office/drawing/2014/main" id="{26FE5DE4-558F-4972-C56C-F2EF37D09506}"/>
+              </a:ext>
+            </a:extLst>
+          </p:cNvPr>
+          <p:cNvSpPr txBox="1"/>
+          <p:nvPr/>
+        </p:nvSpPr>
+        <p:spPr>
+          <a:xfrm>
+            <a:off x="4931337" y="2976848"/>
+            <a:ext cx="4031873" cy="523220"/>
+          </a:xfrm>
+          <a:prstGeom prst="rect">
+            <a:avLst/>
+          </a:prstGeom>
+          <a:noFill/>
+        </p:spPr>
+        <p:txBody>
+          <a:bodyPr wrap="none" rtlCol="0">
+            <a:spAutoFit/>
+          </a:bodyPr>
+          <a:lstStyle/>
+          <a:p>
+            <a:r>
+              <a:rPr lang="en-US" b="1" dirty="0"/>
+              <a:t>How many tests are needed to satisfy </a:t>
+            </a:r>
+            <a:r>
+              <a:rPr lang="en-US" b="1" dirty="0" err="1"/>
+              <a:t>ACoC</a:t>
+            </a:r>
+            <a:r>
+              <a:rPr lang="en-US" b="1" dirty="0"/>
+              <a:t>?</a:t>
+            </a:r>
+          </a:p>
+          <a:p>
+            <a:endParaRPr lang="en-US" b="1" dirty="0"/>
+          </a:p>
+        </p:txBody>
+      </p:sp>
+    </p:spTree>
+    <p:extLst>
+      <p:ext uri="{BB962C8B-B14F-4D97-AF65-F5344CB8AC3E}">
+        <p14:creationId xmlns:p14="http://schemas.microsoft.com/office/powerpoint/2010/main" val="3900228611"/>
+      </p:ext>
+    </p:extLst>
+  </p:cSld>
+  <p:clrMapOvr>
+    <a:masterClrMapping/>
+  </p:clrMapOvr>
+</p:sld>
+</file>
+
+<file path=ppt/slides/slide33.xml><?xml version="1.0" encoding="utf-8"?>
+<p:sld xmlns:a="http://schemas.openxmlformats.org/drawingml/2006/main" xmlns:r="http://schemas.openxmlformats.org/officeDocument/2006/relationships" xmlns:p="http://schemas.openxmlformats.org/presentationml/2006/main">
+  <p:cSld>
+    <p:spTree>
+      <p:nvGrpSpPr>
+        <p:cNvPr id="1" name=""/>
+        <p:cNvGrpSpPr/>
+        <p:nvPr/>
+      </p:nvGrpSpPr>
+      <p:grpSpPr>
+        <a:xfrm>
+          <a:off x="0" y="0"/>
+          <a:ext cx="0" cy="0"/>
+          <a:chOff x="0" y="0"/>
+          <a:chExt cx="0" cy="0"/>
+        </a:xfrm>
+      </p:grpSpPr>
+      <p:sp>
+        <p:nvSpPr>
+          <p:cNvPr id="2" name="Title 1">
+            <a:extLst>
+              <a:ext uri="{FF2B5EF4-FFF2-40B4-BE49-F238E27FC236}">
+                <a16:creationId xmlns:a16="http://schemas.microsoft.com/office/drawing/2014/main" id="{743E8C50-F772-667D-B546-4957C2688CE9}"/>
+              </a:ext>
+            </a:extLst>
+          </p:cNvPr>
+          <p:cNvSpPr>
+            <a:spLocks noGrp="1"/>
+          </p:cNvSpPr>
+          <p:nvPr>
+            <p:ph type="title"/>
+          </p:nvPr>
+        </p:nvSpPr>
+        <p:spPr/>
+        <p:txBody>
+          <a:bodyPr>
+            <a:normAutofit fontScale="90000"/>
+          </a:bodyPr>
+          <a:lstStyle/>
+          <a:p>
+            <a:r>
+              <a:rPr lang="en-US" dirty="0"/>
+              <a:t>All combinations criterion (</a:t>
+            </a:r>
+            <a:r>
+              <a:rPr lang="en-US" dirty="0" err="1"/>
+              <a:t>ACoC</a:t>
+            </a:r>
+            <a:r>
+              <a:rPr lang="en-US" dirty="0"/>
+              <a:t>)</a:t>
+            </a:r>
+            <a:br>
+              <a:rPr lang="en-US" dirty="0"/>
+            </a:br>
+            <a:endParaRPr lang="en-US" dirty="0"/>
+          </a:p>
+        </p:txBody>
+      </p:sp>
+      <p:sp>
+        <p:nvSpPr>
+          <p:cNvPr id="3" name="Text Placeholder 2">
+            <a:extLst>
+              <a:ext uri="{FF2B5EF4-FFF2-40B4-BE49-F238E27FC236}">
+                <a16:creationId xmlns:a16="http://schemas.microsoft.com/office/drawing/2014/main" id="{A2234C0F-AAA5-ACAA-1104-B175583B0652}"/>
+              </a:ext>
+            </a:extLst>
+          </p:cNvPr>
+          <p:cNvSpPr>
+            <a:spLocks noGrp="1"/>
+          </p:cNvSpPr>
+          <p:nvPr>
+            <p:ph type="body" idx="1"/>
+          </p:nvPr>
+        </p:nvSpPr>
+        <p:spPr/>
+        <p:txBody>
+          <a:bodyPr/>
+          <a:lstStyle/>
+          <a:p>
+            <a:endParaRPr lang="en-US" dirty="0"/>
+          </a:p>
+        </p:txBody>
+      </p:sp>
+      <p:pic>
+        <p:nvPicPr>
+          <p:cNvPr id="4" name="table">
+            <a:extLst>
+              <a:ext uri="{FF2B5EF4-FFF2-40B4-BE49-F238E27FC236}">
+                <a16:creationId xmlns:a16="http://schemas.microsoft.com/office/drawing/2014/main" id="{4F63EB56-C272-7B96-0702-87E10EC5D8CF}"/>
+              </a:ext>
+            </a:extLst>
+          </p:cNvPr>
+          <p:cNvPicPr>
+            <a:picLocks noChangeAspect="1"/>
+          </p:cNvPicPr>
+          <p:nvPr/>
+        </p:nvPicPr>
+        <p:blipFill>
+          <a:blip r:embed="rId2"/>
+          <a:stretch>
+            <a:fillRect/>
+          </a:stretch>
+        </p:blipFill>
+        <p:spPr>
+          <a:xfrm>
+            <a:off x="240956" y="1200150"/>
+            <a:ext cx="8662088" cy="2743200"/>
+          </a:xfrm>
+          <a:prstGeom prst="rect">
+            <a:avLst/>
+          </a:prstGeom>
+        </p:spPr>
+      </p:pic>
+    </p:spTree>
+    <p:extLst>
+      <p:ext uri="{BB962C8B-B14F-4D97-AF65-F5344CB8AC3E}">
+        <p14:creationId xmlns:p14="http://schemas.microsoft.com/office/powerpoint/2010/main" val="1716914462"/>
+      </p:ext>
+    </p:extLst>
+  </p:cSld>
+  <p:clrMapOvr>
+    <a:masterClrMapping/>
+  </p:clrMapOvr>
+</p:sld>
+</file>
+
+<file path=ppt/slides/slide34.xml><?xml version="1.0" encoding="utf-8"?>
+<p:sld xmlns:a="http://schemas.openxmlformats.org/drawingml/2006/main" xmlns:r="http://schemas.openxmlformats.org/officeDocument/2006/relationships" xmlns:p="http://schemas.openxmlformats.org/presentationml/2006/main">
+  <p:cSld>
+    <p:spTree>
+      <p:nvGrpSpPr>
+        <p:cNvPr id="1" name=""/>
+        <p:cNvGrpSpPr/>
+        <p:nvPr/>
+      </p:nvGrpSpPr>
+      <p:grpSpPr>
+        <a:xfrm>
+          <a:off x="0" y="0"/>
+          <a:ext cx="0" cy="0"/>
+          <a:chOff x="0" y="0"/>
+          <a:chExt cx="0" cy="0"/>
+        </a:xfrm>
+      </p:grpSpPr>
+      <p:sp>
+        <p:nvSpPr>
+          <p:cNvPr id="2" name="Title 1">
+            <a:extLst>
+              <a:ext uri="{FF2B5EF4-FFF2-40B4-BE49-F238E27FC236}">
+                <a16:creationId xmlns:a16="http://schemas.microsoft.com/office/drawing/2014/main" id="{A3E7E283-CA95-A308-436D-7EF23ED730C5}"/>
+              </a:ext>
+            </a:extLst>
+          </p:cNvPr>
+          <p:cNvSpPr>
+            <a:spLocks noGrp="1"/>
+          </p:cNvSpPr>
+          <p:nvPr>
+            <p:ph type="title"/>
+          </p:nvPr>
+        </p:nvSpPr>
+        <p:spPr/>
+        <p:txBody>
+          <a:bodyPr>
+            <a:normAutofit fontScale="90000"/>
+          </a:bodyPr>
+          <a:lstStyle/>
+          <a:p>
+            <a:r>
+              <a:rPr lang="en-US" dirty="0"/>
+              <a:t>Each Choice Coverage (ECC) </a:t>
+            </a:r>
+          </a:p>
+        </p:txBody>
+      </p:sp>
+      <p:sp>
+        <p:nvSpPr>
+          <p:cNvPr id="3" name="Text Placeholder 2">
+            <a:extLst>
+              <a:ext uri="{FF2B5EF4-FFF2-40B4-BE49-F238E27FC236}">
+                <a16:creationId xmlns:a16="http://schemas.microsoft.com/office/drawing/2014/main" id="{E7CB0FFA-FFC8-6699-FE94-6106D663AE67}"/>
+              </a:ext>
+            </a:extLst>
+          </p:cNvPr>
+          <p:cNvSpPr>
+            <a:spLocks noGrp="1"/>
+          </p:cNvSpPr>
+          <p:nvPr>
+            <p:ph type="body" idx="1"/>
+          </p:nvPr>
+        </p:nvSpPr>
+        <p:spPr/>
+        <p:txBody>
+          <a:bodyPr/>
+          <a:lstStyle/>
+          <a:p>
+            <a:r>
+              <a:rPr lang="en-US" dirty="0"/>
+              <a:t>Use at least one value from each block for each characteristic in at least one test case.</a:t>
+            </a:r>
+          </a:p>
+          <a:p>
+            <a:r>
+              <a:rPr lang="en-US" dirty="0"/>
+              <a:t>4 Characteristics:  A, B, C, D</a:t>
+            </a:r>
+          </a:p>
+          <a:p>
+            <a:r>
+              <a:rPr lang="en-US" dirty="0"/>
+              <a:t>Abstract blocks: A = [a1, a2]; B = [b1, b2];</a:t>
+            </a:r>
+          </a:p>
+          <a:p>
+            <a:r>
+              <a:rPr lang="en-US" dirty="0"/>
+              <a:t>		       C = [c1, c2, c3]; D = [d1, d2]</a:t>
+            </a:r>
+          </a:p>
+          <a:p>
+            <a:endParaRPr lang="en-US" dirty="0"/>
+          </a:p>
+          <a:p>
+            <a:r>
+              <a:rPr lang="en-US" dirty="0"/>
+              <a:t>How many tests are needed for ECC?</a:t>
+            </a:r>
+          </a:p>
+          <a:p>
+            <a:r>
+              <a:rPr lang="en-US" dirty="0"/>
+              <a:t>Design the (abstract) tests</a:t>
+            </a:r>
+          </a:p>
+          <a:p>
+            <a:endParaRPr lang="en-US" dirty="0"/>
+          </a:p>
+        </p:txBody>
+      </p:sp>
+    </p:spTree>
+    <p:extLst>
+      <p:ext uri="{BB962C8B-B14F-4D97-AF65-F5344CB8AC3E}">
+        <p14:creationId xmlns:p14="http://schemas.microsoft.com/office/powerpoint/2010/main" val="3741851327"/>
+      </p:ext>
+    </p:extLst>
+  </p:cSld>
+  <p:clrMapOvr>
+    <a:masterClrMapping/>
+  </p:clrMapOvr>
+</p:sld>
+</file>
+
+<file path=ppt/slides/slide35.xml><?xml version="1.0" encoding="utf-8"?>
+<p:sld xmlns:a="http://schemas.openxmlformats.org/drawingml/2006/main" xmlns:r="http://schemas.openxmlformats.org/officeDocument/2006/relationships" xmlns:p="http://schemas.openxmlformats.org/presentationml/2006/main">
+  <p:cSld>
+    <p:spTree>
+      <p:nvGrpSpPr>
+        <p:cNvPr id="1" name="">
+          <a:extLst>
+            <a:ext uri="{FF2B5EF4-FFF2-40B4-BE49-F238E27FC236}">
+              <a16:creationId xmlns:a16="http://schemas.microsoft.com/office/drawing/2014/main" id="{58FCD32E-7EE9-EEF1-8E65-FC942DA367BA}"/>
+            </a:ext>
+          </a:extLst>
+        </p:cNvPr>
+        <p:cNvGrpSpPr/>
+        <p:nvPr/>
+      </p:nvGrpSpPr>
+      <p:grpSpPr>
+        <a:xfrm>
+          <a:off x="0" y="0"/>
+          <a:ext cx="0" cy="0"/>
+          <a:chOff x="0" y="0"/>
+          <a:chExt cx="0" cy="0"/>
+        </a:xfrm>
+      </p:grpSpPr>
+      <p:sp>
+        <p:nvSpPr>
+          <p:cNvPr id="2" name="Title 1">
+            <a:extLst>
+              <a:ext uri="{FF2B5EF4-FFF2-40B4-BE49-F238E27FC236}">
+                <a16:creationId xmlns:a16="http://schemas.microsoft.com/office/drawing/2014/main" id="{D5B9E183-D4CD-BE4C-166B-02442781D468}"/>
+              </a:ext>
+            </a:extLst>
+          </p:cNvPr>
+          <p:cNvSpPr>
+            <a:spLocks noGrp="1"/>
+          </p:cNvSpPr>
+          <p:nvPr>
+            <p:ph type="title"/>
+          </p:nvPr>
+        </p:nvSpPr>
+        <p:spPr/>
+        <p:txBody>
+          <a:bodyPr>
+            <a:normAutofit fontScale="90000"/>
+          </a:bodyPr>
+          <a:lstStyle/>
+          <a:p>
+            <a:r>
+              <a:rPr lang="en-US" dirty="0"/>
+              <a:t>Each Choice Coverage (ECC) </a:t>
+            </a:r>
+          </a:p>
+        </p:txBody>
+      </p:sp>
+      <p:sp>
+        <p:nvSpPr>
+          <p:cNvPr id="3" name="Text Placeholder 2">
+            <a:extLst>
+              <a:ext uri="{FF2B5EF4-FFF2-40B4-BE49-F238E27FC236}">
+                <a16:creationId xmlns:a16="http://schemas.microsoft.com/office/drawing/2014/main" id="{7546F0C2-6022-9E95-96BD-AB57EBB1072A}"/>
+              </a:ext>
+            </a:extLst>
+          </p:cNvPr>
+          <p:cNvSpPr>
+            <a:spLocks noGrp="1"/>
+          </p:cNvSpPr>
+          <p:nvPr>
+            <p:ph type="body" idx="1"/>
+          </p:nvPr>
+        </p:nvSpPr>
+        <p:spPr/>
+        <p:txBody>
+          <a:bodyPr/>
+          <a:lstStyle/>
+          <a:p>
+            <a:r>
+              <a:rPr lang="en-US" dirty="0"/>
+              <a:t>Use at least one value from each block for each characteristic in at least one test case.</a:t>
+            </a:r>
+          </a:p>
+          <a:p>
+            <a:r>
+              <a:rPr lang="en-US" dirty="0"/>
+              <a:t>4 Characteristics:  A, B, C, D</a:t>
+            </a:r>
+          </a:p>
+          <a:p>
+            <a:r>
+              <a:rPr lang="en-US" dirty="0"/>
+              <a:t>Abstract blocks: A = [a1, a2]; B = [b1, b2];</a:t>
+            </a:r>
+          </a:p>
+          <a:p>
+            <a:r>
+              <a:rPr lang="en-US" dirty="0"/>
+              <a:t>		       C = [c1, c2, c3]; D = [d1, d2]</a:t>
+            </a:r>
+          </a:p>
+          <a:p>
+            <a:endParaRPr lang="en-US" dirty="0"/>
+          </a:p>
+          <a:p>
+            <a:r>
+              <a:rPr lang="en-US" dirty="0"/>
+              <a:t>How many tests are needed for ECC?</a:t>
+            </a:r>
+          </a:p>
+          <a:p>
+            <a:r>
+              <a:rPr lang="en-US" dirty="0"/>
+              <a:t>Design the (abstract) tests</a:t>
+            </a:r>
+          </a:p>
+          <a:p>
+            <a:endParaRPr lang="en-US" dirty="0"/>
+          </a:p>
+        </p:txBody>
+      </p:sp>
+      <p:pic>
+        <p:nvPicPr>
+          <p:cNvPr id="4" name="table">
+            <a:extLst>
+              <a:ext uri="{FF2B5EF4-FFF2-40B4-BE49-F238E27FC236}">
+                <a16:creationId xmlns:a16="http://schemas.microsoft.com/office/drawing/2014/main" id="{C9365BA0-CAFE-3746-F5A8-18D42CB1A590}"/>
+              </a:ext>
+            </a:extLst>
+          </p:cNvPr>
+          <p:cNvPicPr>
+            <a:picLocks noChangeAspect="1"/>
+          </p:cNvPicPr>
+          <p:nvPr/>
+        </p:nvPicPr>
+        <p:blipFill>
+          <a:blip r:embed="rId2"/>
+          <a:stretch>
+            <a:fillRect/>
+          </a:stretch>
+        </p:blipFill>
+        <p:spPr>
+          <a:xfrm>
+            <a:off x="6143062" y="3620646"/>
+            <a:ext cx="2165522" cy="1371600"/>
+          </a:xfrm>
+          <a:prstGeom prst="rect">
+            <a:avLst/>
+          </a:prstGeom>
+        </p:spPr>
+      </p:pic>
+    </p:spTree>
+    <p:extLst>
+      <p:ext uri="{BB962C8B-B14F-4D97-AF65-F5344CB8AC3E}">
+        <p14:creationId xmlns:p14="http://schemas.microsoft.com/office/powerpoint/2010/main" val="1975753515"/>
+      </p:ext>
+    </p:extLst>
+  </p:cSld>
+  <p:clrMapOvr>
+    <a:masterClrMapping/>
+  </p:clrMapOvr>
+</p:sld>
+</file>
+
+<file path=ppt/slides/slide36.xml><?xml version="1.0" encoding="utf-8"?>
+<p:sld xmlns:a="http://schemas.openxmlformats.org/drawingml/2006/main" xmlns:r="http://schemas.openxmlformats.org/officeDocument/2006/relationships" xmlns:p="http://schemas.openxmlformats.org/presentationml/2006/main">
+  <p:cSld>
+    <p:spTree>
+      <p:nvGrpSpPr>
+        <p:cNvPr id="1" name=""/>
+        <p:cNvGrpSpPr/>
+        <p:nvPr/>
+      </p:nvGrpSpPr>
+      <p:grpSpPr>
+        <a:xfrm>
+          <a:off x="0" y="0"/>
+          <a:ext cx="0" cy="0"/>
+          <a:chOff x="0" y="0"/>
+          <a:chExt cx="0" cy="0"/>
+        </a:xfrm>
+      </p:grpSpPr>
+      <p:sp>
+        <p:nvSpPr>
+          <p:cNvPr id="2" name="Title 1">
+            <a:extLst>
+              <a:ext uri="{FF2B5EF4-FFF2-40B4-BE49-F238E27FC236}">
+                <a16:creationId xmlns:a16="http://schemas.microsoft.com/office/drawing/2014/main" id="{71CD2139-826E-6101-0B59-793D59FCC876}"/>
+              </a:ext>
+            </a:extLst>
+          </p:cNvPr>
+          <p:cNvSpPr>
+            <a:spLocks noGrp="1"/>
+          </p:cNvSpPr>
+          <p:nvPr>
+            <p:ph type="title"/>
+          </p:nvPr>
+        </p:nvSpPr>
+        <p:spPr/>
+        <p:txBody>
+          <a:bodyPr>
+            <a:normAutofit fontScale="90000"/>
+          </a:bodyPr>
+          <a:lstStyle/>
+          <a:p>
+            <a:r>
+              <a:rPr lang="en-US" dirty="0"/>
+              <a:t>Base Choice Coverage (BCC)</a:t>
+            </a:r>
+          </a:p>
+        </p:txBody>
+      </p:sp>
+      <p:sp>
+        <p:nvSpPr>
+          <p:cNvPr id="3" name="Text Placeholder 2">
+            <a:extLst>
+              <a:ext uri="{FF2B5EF4-FFF2-40B4-BE49-F238E27FC236}">
+                <a16:creationId xmlns:a16="http://schemas.microsoft.com/office/drawing/2014/main" id="{7679FA2C-5639-4250-5E47-009C1EB23529}"/>
+              </a:ext>
+            </a:extLst>
+          </p:cNvPr>
+          <p:cNvSpPr>
+            <a:spLocks noGrp="1"/>
+          </p:cNvSpPr>
+          <p:nvPr>
+            <p:ph type="body" idx="1"/>
+          </p:nvPr>
+        </p:nvSpPr>
+        <p:spPr/>
+        <p:txBody>
+          <a:bodyPr/>
+          <a:lstStyle/>
+          <a:p>
+            <a:r>
+              <a:rPr lang="en-US" dirty="0"/>
+              <a:t>Choose a base choice block for each characteristic. Form a base test by using the base choice for each characteristic.  Choose subsequent tests by holding all but one base choice constant and using each non-base choice in each other characteristic.</a:t>
+            </a:r>
+          </a:p>
+        </p:txBody>
+      </p:sp>
+    </p:spTree>
+    <p:extLst>
+      <p:ext uri="{BB962C8B-B14F-4D97-AF65-F5344CB8AC3E}">
+        <p14:creationId xmlns:p14="http://schemas.microsoft.com/office/powerpoint/2010/main" val="387367791"/>
+      </p:ext>
+    </p:extLst>
+  </p:cSld>
+  <p:clrMapOvr>
+    <a:masterClrMapping/>
+  </p:clrMapOvr>
+</p:sld>
+</file>
+
+<file path=ppt/slides/slide37.xml><?xml version="1.0" encoding="utf-8"?>
+<p:sld xmlns:a="http://schemas.openxmlformats.org/drawingml/2006/main" xmlns:r="http://schemas.openxmlformats.org/officeDocument/2006/relationships" xmlns:p="http://schemas.openxmlformats.org/presentationml/2006/main">
+  <p:cSld>
+    <p:spTree>
+      <p:nvGrpSpPr>
+        <p:cNvPr id="1" name=""/>
+        <p:cNvGrpSpPr/>
+        <p:nvPr/>
+      </p:nvGrpSpPr>
+      <p:grpSpPr>
+        <a:xfrm>
+          <a:off x="0" y="0"/>
+          <a:ext cx="0" cy="0"/>
+          <a:chOff x="0" y="0"/>
+          <a:chExt cx="0" cy="0"/>
+        </a:xfrm>
+      </p:grpSpPr>
+      <p:sp>
+        <p:nvSpPr>
+          <p:cNvPr id="2" name="Title 1">
+            <a:extLst>
+              <a:ext uri="{FF2B5EF4-FFF2-40B4-BE49-F238E27FC236}">
+                <a16:creationId xmlns:a16="http://schemas.microsoft.com/office/drawing/2014/main" id="{4754B4F9-58A1-1493-9DEF-D047FF2BD1F5}"/>
+              </a:ext>
+            </a:extLst>
+          </p:cNvPr>
+          <p:cNvSpPr>
+            <a:spLocks noGrp="1"/>
+          </p:cNvSpPr>
+          <p:nvPr>
+            <p:ph type="title"/>
+          </p:nvPr>
+        </p:nvSpPr>
+        <p:spPr/>
+        <p:txBody>
+          <a:bodyPr>
+            <a:normAutofit fontScale="90000"/>
+          </a:bodyPr>
+          <a:lstStyle/>
+          <a:p>
+            <a:r>
+              <a:rPr lang="en-US" dirty="0"/>
+              <a:t>Base choice notes</a:t>
+            </a:r>
+          </a:p>
+        </p:txBody>
+      </p:sp>
+      <p:sp>
+        <p:nvSpPr>
+          <p:cNvPr id="3" name="Text Placeholder 2">
+            <a:extLst>
+              <a:ext uri="{FF2B5EF4-FFF2-40B4-BE49-F238E27FC236}">
+                <a16:creationId xmlns:a16="http://schemas.microsoft.com/office/drawing/2014/main" id="{FA3535CE-05E0-71A4-3FD1-E0C0C80305B4}"/>
+              </a:ext>
+            </a:extLst>
+          </p:cNvPr>
+          <p:cNvSpPr>
+            <a:spLocks noGrp="1"/>
+          </p:cNvSpPr>
+          <p:nvPr>
+            <p:ph type="body" idx="1"/>
+          </p:nvPr>
+        </p:nvSpPr>
+        <p:spPr/>
+        <p:txBody>
+          <a:bodyPr/>
+          <a:lstStyle/>
+          <a:p>
+            <a:r>
+              <a:rPr lang="en-US" dirty="0"/>
+              <a:t>The base test must be feasible</a:t>
+            </a:r>
+          </a:p>
+          <a:p>
+            <a:pPr lvl="1"/>
+            <a:r>
+              <a:rPr lang="en-US" dirty="0"/>
+              <a:t>That is, all base choices must be compatible</a:t>
+            </a:r>
+          </a:p>
+          <a:p>
+            <a:r>
+              <a:rPr lang="en-US" dirty="0"/>
+              <a:t>Base choices can be</a:t>
+            </a:r>
+          </a:p>
+          <a:p>
+            <a:pPr lvl="1"/>
+            <a:r>
+              <a:rPr lang="en-US" dirty="0"/>
+              <a:t>Most likely from an end-use point of view</a:t>
+            </a:r>
+          </a:p>
+          <a:p>
+            <a:pPr lvl="1"/>
+            <a:r>
+              <a:rPr lang="en-US" dirty="0"/>
+              <a:t>Simplest</a:t>
+            </a:r>
+          </a:p>
+          <a:p>
+            <a:pPr lvl="1"/>
+            <a:r>
+              <a:rPr lang="en-US" dirty="0"/>
+              <a:t>Smallest</a:t>
+            </a:r>
+          </a:p>
+          <a:p>
+            <a:pPr lvl="1"/>
+            <a:r>
+              <a:rPr lang="en-US" dirty="0"/>
+              <a:t>First in some ordering</a:t>
+            </a:r>
+          </a:p>
+          <a:p>
+            <a:r>
+              <a:rPr lang="en-US" dirty="0"/>
+              <a:t>Happy path tests often make good base choices</a:t>
+            </a:r>
+          </a:p>
+          <a:p>
+            <a:r>
+              <a:rPr lang="en-US" dirty="0"/>
+              <a:t>The base choice is a crucial design decision</a:t>
+            </a:r>
+          </a:p>
+          <a:p>
+            <a:pPr lvl="1"/>
+            <a:r>
+              <a:rPr lang="en-US" dirty="0"/>
+              <a:t>Test designers should document why the choices were made</a:t>
+            </a:r>
+          </a:p>
+          <a:p>
+            <a:endParaRPr lang="en-US" dirty="0"/>
+          </a:p>
+        </p:txBody>
+      </p:sp>
+    </p:spTree>
+    <p:extLst>
+      <p:ext uri="{BB962C8B-B14F-4D97-AF65-F5344CB8AC3E}">
+        <p14:creationId xmlns:p14="http://schemas.microsoft.com/office/powerpoint/2010/main" val="3383950534"/>
+      </p:ext>
+    </p:extLst>
+  </p:cSld>
+  <p:clrMapOvr>
+    <a:masterClrMapping/>
+  </p:clrMapOvr>
+</p:sld>
+</file>
+
+<file path=ppt/slides/slide38.xml><?xml version="1.0" encoding="utf-8"?>
+<p:sld xmlns:a="http://schemas.openxmlformats.org/drawingml/2006/main" xmlns:r="http://schemas.openxmlformats.org/officeDocument/2006/relationships" xmlns:p="http://schemas.openxmlformats.org/presentationml/2006/main">
+  <p:cSld>
+    <p:spTree>
+      <p:nvGrpSpPr>
+        <p:cNvPr id="1" name=""/>
+        <p:cNvGrpSpPr/>
+        <p:nvPr/>
+      </p:nvGrpSpPr>
+      <p:grpSpPr>
+        <a:xfrm>
+          <a:off x="0" y="0"/>
+          <a:ext cx="0" cy="0"/>
+          <a:chOff x="0" y="0"/>
+          <a:chExt cx="0" cy="0"/>
+        </a:xfrm>
+      </p:grpSpPr>
+      <p:sp>
+        <p:nvSpPr>
+          <p:cNvPr id="2" name="Title 1">
+            <a:extLst>
+              <a:ext uri="{FF2B5EF4-FFF2-40B4-BE49-F238E27FC236}">
+                <a16:creationId xmlns:a16="http://schemas.microsoft.com/office/drawing/2014/main" id="{3B73B437-2526-21B1-389A-3B31CAE84E52}"/>
+              </a:ext>
+            </a:extLst>
+          </p:cNvPr>
+          <p:cNvSpPr>
+            <a:spLocks noGrp="1"/>
+          </p:cNvSpPr>
+          <p:nvPr>
+            <p:ph type="title"/>
+          </p:nvPr>
+        </p:nvSpPr>
+        <p:spPr/>
+        <p:txBody>
+          <a:bodyPr>
+            <a:normAutofit fontScale="90000"/>
+          </a:bodyPr>
+          <a:lstStyle/>
+          <a:p>
+            <a:r>
+              <a:rPr lang="en-US" dirty="0"/>
+              <a:t>An Example for BCC</a:t>
+            </a:r>
+          </a:p>
+        </p:txBody>
+      </p:sp>
+      <p:sp>
+        <p:nvSpPr>
+          <p:cNvPr id="3" name="Text Placeholder 2">
+            <a:extLst>
+              <a:ext uri="{FF2B5EF4-FFF2-40B4-BE49-F238E27FC236}">
+                <a16:creationId xmlns:a16="http://schemas.microsoft.com/office/drawing/2014/main" id="{6896B170-913F-51F0-F50F-0C0CCCB054EE}"/>
+              </a:ext>
+            </a:extLst>
+          </p:cNvPr>
+          <p:cNvSpPr>
+            <a:spLocks noGrp="1"/>
+          </p:cNvSpPr>
+          <p:nvPr>
+            <p:ph type="body" idx="1"/>
+          </p:nvPr>
+        </p:nvSpPr>
+        <p:spPr/>
+        <p:txBody>
+          <a:bodyPr/>
+          <a:lstStyle/>
+          <a:p>
+            <a:r>
+              <a:rPr lang="en-US" dirty="0"/>
+              <a:t>4 Characteristics:  A, B, C, D</a:t>
+            </a:r>
+          </a:p>
+          <a:p>
+            <a:r>
+              <a:rPr lang="en-US" dirty="0"/>
+              <a:t>Abstract blocks: A = [a1, a2]; B = [b1, b2];</a:t>
+            </a:r>
+          </a:p>
+          <a:p>
+            <a:r>
+              <a:rPr lang="en-US" dirty="0"/>
+              <a:t>		       C = [c1, c2, c3]; D = [d1, d2]</a:t>
+            </a:r>
+          </a:p>
+          <a:p>
+            <a:r>
+              <a:rPr lang="en-US" dirty="0"/>
+              <a:t>How many tests are needed for BCC?</a:t>
+            </a:r>
+          </a:p>
+          <a:p>
+            <a:r>
+              <a:rPr lang="en-US" dirty="0"/>
+              <a:t>Pick base values and write one base test</a:t>
+            </a:r>
+          </a:p>
+          <a:p>
+            <a:r>
+              <a:rPr lang="en-US" dirty="0"/>
+              <a:t>Design the remaining (abstract) tests</a:t>
+            </a:r>
+          </a:p>
+          <a:p>
+            <a:endParaRPr lang="en-US" dirty="0"/>
+          </a:p>
+        </p:txBody>
+      </p:sp>
+    </p:spTree>
+    <p:extLst>
+      <p:ext uri="{BB962C8B-B14F-4D97-AF65-F5344CB8AC3E}">
+        <p14:creationId xmlns:p14="http://schemas.microsoft.com/office/powerpoint/2010/main" val="1584945895"/>
+      </p:ext>
+    </p:extLst>
+  </p:cSld>
+  <p:clrMapOvr>
+    <a:masterClrMapping/>
+  </p:clrMapOvr>
+</p:sld>
+</file>
+
+<file path=ppt/slides/slide39.xml><?xml version="1.0" encoding="utf-8"?>
+<p:sld xmlns:a="http://schemas.openxmlformats.org/drawingml/2006/main" xmlns:r="http://schemas.openxmlformats.org/officeDocument/2006/relationships" xmlns:p="http://schemas.openxmlformats.org/presentationml/2006/main">
+  <p:cSld>
+    <p:spTree>
+      <p:nvGrpSpPr>
+        <p:cNvPr id="1" name="">
+          <a:extLst>
+            <a:ext uri="{FF2B5EF4-FFF2-40B4-BE49-F238E27FC236}">
+              <a16:creationId xmlns:a16="http://schemas.microsoft.com/office/drawing/2014/main" id="{19CF3798-87A8-BFD9-2DE5-D1D952B36DC8}"/>
+            </a:ext>
+          </a:extLst>
+        </p:cNvPr>
+        <p:cNvGrpSpPr/>
+        <p:nvPr/>
+      </p:nvGrpSpPr>
+      <p:grpSpPr>
+        <a:xfrm>
+          <a:off x="0" y="0"/>
+          <a:ext cx="0" cy="0"/>
+          <a:chOff x="0" y="0"/>
+          <a:chExt cx="0" cy="0"/>
+        </a:xfrm>
+      </p:grpSpPr>
+      <p:sp>
+        <p:nvSpPr>
+          <p:cNvPr id="2" name="Title 1">
+            <a:extLst>
+              <a:ext uri="{FF2B5EF4-FFF2-40B4-BE49-F238E27FC236}">
+                <a16:creationId xmlns:a16="http://schemas.microsoft.com/office/drawing/2014/main" id="{87ED3022-E62C-335E-2FA4-F6AB219A36C5}"/>
+              </a:ext>
+            </a:extLst>
+          </p:cNvPr>
+          <p:cNvSpPr>
+            <a:spLocks noGrp="1"/>
+          </p:cNvSpPr>
+          <p:nvPr>
+            <p:ph type="title"/>
+          </p:nvPr>
+        </p:nvSpPr>
+        <p:spPr/>
+        <p:txBody>
+          <a:bodyPr>
+            <a:normAutofit fontScale="90000"/>
+          </a:bodyPr>
+          <a:lstStyle/>
+          <a:p>
+            <a:r>
+              <a:rPr lang="en-US" dirty="0"/>
+              <a:t>An Example for BCC</a:t>
+            </a:r>
+          </a:p>
+        </p:txBody>
+      </p:sp>
+      <p:sp>
+        <p:nvSpPr>
+          <p:cNvPr id="3" name="Text Placeholder 2">
+            <a:extLst>
+              <a:ext uri="{FF2B5EF4-FFF2-40B4-BE49-F238E27FC236}">
+                <a16:creationId xmlns:a16="http://schemas.microsoft.com/office/drawing/2014/main" id="{C7753FD8-BE94-BCC0-C6A4-DBBF8CD068E4}"/>
+              </a:ext>
+            </a:extLst>
+          </p:cNvPr>
+          <p:cNvSpPr>
+            <a:spLocks noGrp="1"/>
+          </p:cNvSpPr>
+          <p:nvPr>
+            <p:ph type="body" idx="1"/>
+          </p:nvPr>
+        </p:nvSpPr>
+        <p:spPr/>
+        <p:txBody>
+          <a:bodyPr/>
+          <a:lstStyle/>
+          <a:p>
+            <a:r>
+              <a:rPr lang="en-US" dirty="0"/>
+              <a:t>4 Characteristics:  A, B, C, D</a:t>
+            </a:r>
+          </a:p>
+          <a:p>
+            <a:r>
+              <a:rPr lang="en-US" dirty="0"/>
+              <a:t>Abstract blocks: A = [a1, a2]; B = [b1, b2];</a:t>
+            </a:r>
+          </a:p>
+          <a:p>
+            <a:r>
+              <a:rPr lang="en-US" dirty="0"/>
+              <a:t>		       C = [c1, c2, c3]; D = [d1, d2]</a:t>
+            </a:r>
+          </a:p>
+          <a:p>
+            <a:r>
+              <a:rPr lang="en-US" dirty="0"/>
+              <a:t>How many tests are needed for BCC?</a:t>
+            </a:r>
+          </a:p>
+          <a:p>
+            <a:r>
+              <a:rPr lang="en-US" dirty="0"/>
+              <a:t>Pick base values and write one base test</a:t>
+            </a:r>
+          </a:p>
+          <a:p>
+            <a:r>
+              <a:rPr lang="en-US" dirty="0"/>
+              <a:t>Design the remaining (abstract) tests</a:t>
+            </a:r>
+          </a:p>
+          <a:p>
+            <a:endParaRPr lang="en-US" dirty="0"/>
+          </a:p>
+        </p:txBody>
+      </p:sp>
+      <p:pic>
+        <p:nvPicPr>
+          <p:cNvPr id="4" name="table">
+            <a:extLst>
+              <a:ext uri="{FF2B5EF4-FFF2-40B4-BE49-F238E27FC236}">
+                <a16:creationId xmlns:a16="http://schemas.microsoft.com/office/drawing/2014/main" id="{FD1B2E54-1F48-94A3-F988-3EC75763067E}"/>
+              </a:ext>
+            </a:extLst>
+          </p:cNvPr>
+          <p:cNvPicPr>
+            <a:picLocks noChangeAspect="1"/>
+          </p:cNvPicPr>
+          <p:nvPr/>
+        </p:nvPicPr>
+        <p:blipFill>
+          <a:blip r:embed="rId2"/>
+          <a:stretch>
+            <a:fillRect/>
+          </a:stretch>
+        </p:blipFill>
+        <p:spPr>
+          <a:xfrm>
+            <a:off x="4925507" y="2724486"/>
+            <a:ext cx="3982181" cy="2533077"/>
+          </a:xfrm>
+          <a:prstGeom prst="rect">
+            <a:avLst/>
+          </a:prstGeom>
+        </p:spPr>
+      </p:pic>
+    </p:spTree>
+    <p:extLst>
+      <p:ext uri="{BB962C8B-B14F-4D97-AF65-F5344CB8AC3E}">
+        <p14:creationId xmlns:p14="http://schemas.microsoft.com/office/powerpoint/2010/main" val="1869708264"/>
+      </p:ext>
+    </p:extLst>
   </p:cSld>
   <p:clrMapOvr>
     <a:masterClrMapping/>
@@ -11603,6 +14093,427 @@
         </p:txBody>
       </p:sp>
     </p:spTree>
+  </p:cSld>
+  <p:clrMapOvr>
+    <a:masterClrMapping/>
+  </p:clrMapOvr>
+</p:sld>
+</file>
+
+<file path=ppt/slides/slide40.xml><?xml version="1.0" encoding="utf-8"?>
+<p:sld xmlns:a="http://schemas.openxmlformats.org/drawingml/2006/main" xmlns:r="http://schemas.openxmlformats.org/officeDocument/2006/relationships" xmlns:p="http://schemas.openxmlformats.org/presentationml/2006/main">
+  <p:cSld>
+    <p:spTree>
+      <p:nvGrpSpPr>
+        <p:cNvPr id="1" name=""/>
+        <p:cNvGrpSpPr/>
+        <p:nvPr/>
+      </p:nvGrpSpPr>
+      <p:grpSpPr>
+        <a:xfrm>
+          <a:off x="0" y="0"/>
+          <a:ext cx="0" cy="0"/>
+          <a:chOff x="0" y="0"/>
+          <a:chExt cx="0" cy="0"/>
+        </a:xfrm>
+      </p:grpSpPr>
+      <p:sp>
+        <p:nvSpPr>
+          <p:cNvPr id="2" name="Title 1">
+            <a:extLst>
+              <a:ext uri="{FF2B5EF4-FFF2-40B4-BE49-F238E27FC236}">
+                <a16:creationId xmlns:a16="http://schemas.microsoft.com/office/drawing/2014/main" id="{170A75CB-2396-8223-7F16-DF7F959FDC23}"/>
+              </a:ext>
+            </a:extLst>
+          </p:cNvPr>
+          <p:cNvSpPr>
+            <a:spLocks noGrp="1"/>
+          </p:cNvSpPr>
+          <p:nvPr>
+            <p:ph type="title"/>
+          </p:nvPr>
+        </p:nvSpPr>
+        <p:spPr/>
+        <p:txBody>
+          <a:bodyPr>
+            <a:normAutofit fontScale="90000"/>
+          </a:bodyPr>
+          <a:lstStyle/>
+          <a:p>
+            <a:r>
+              <a:rPr lang="en-US" dirty="0"/>
+              <a:t>Multiple Base Choice Coverage (MBCC)</a:t>
+            </a:r>
+          </a:p>
+        </p:txBody>
+      </p:sp>
+      <p:sp>
+        <p:nvSpPr>
+          <p:cNvPr id="3" name="Text Placeholder 2">
+            <a:extLst>
+              <a:ext uri="{FF2B5EF4-FFF2-40B4-BE49-F238E27FC236}">
+                <a16:creationId xmlns:a16="http://schemas.microsoft.com/office/drawing/2014/main" id="{6A3FDFE3-8942-D5A8-2321-4FB44A695D0B}"/>
+              </a:ext>
+            </a:extLst>
+          </p:cNvPr>
+          <p:cNvSpPr>
+            <a:spLocks noGrp="1"/>
+          </p:cNvSpPr>
+          <p:nvPr>
+            <p:ph type="body" idx="1"/>
+          </p:nvPr>
+        </p:nvSpPr>
+        <p:spPr/>
+        <p:txBody>
+          <a:bodyPr/>
+          <a:lstStyle/>
+          <a:p>
+            <a:r>
+              <a:rPr lang="en-US" dirty="0"/>
+              <a:t>Choose at least one, and possibly more, base choice blocks for each characteristic. Form base tests by using each base choice for each characteristic at least once. Subsequent tests are chosen by holding all but one base choice constant for each base test and using each non-base choice in each other characteristic.</a:t>
+            </a:r>
+          </a:p>
+          <a:p>
+            <a:r>
+              <a:rPr lang="en-US" dirty="0"/>
+              <a:t>For our example: Two base tests: a1, b1, c1, d1    a2, b2, c2, d2</a:t>
+            </a:r>
+          </a:p>
+          <a:p>
+            <a:r>
+              <a:rPr lang="en-US" dirty="0"/>
+              <a:t>Tests from a1, b1, c1, d1:  a1, b1, c3, d1</a:t>
+            </a:r>
+          </a:p>
+          <a:p>
+            <a:r>
+              <a:rPr lang="en-US" dirty="0"/>
+              <a:t>Tests from a2, b2, c2, d2:  a2, b2, c3, d2</a:t>
+            </a:r>
+          </a:p>
+        </p:txBody>
+      </p:sp>
+    </p:spTree>
+    <p:extLst>
+      <p:ext uri="{BB962C8B-B14F-4D97-AF65-F5344CB8AC3E}">
+        <p14:creationId xmlns:p14="http://schemas.microsoft.com/office/powerpoint/2010/main" val="1160845856"/>
+      </p:ext>
+    </p:extLst>
+  </p:cSld>
+  <p:clrMapOvr>
+    <a:masterClrMapping/>
+  </p:clrMapOvr>
+</p:sld>
+</file>
+
+<file path=ppt/slides/slide41.xml><?xml version="1.0" encoding="utf-8"?>
+<p:sld xmlns:a="http://schemas.openxmlformats.org/drawingml/2006/main" xmlns:r="http://schemas.openxmlformats.org/officeDocument/2006/relationships" xmlns:p="http://schemas.openxmlformats.org/presentationml/2006/main">
+  <p:cSld>
+    <p:spTree>
+      <p:nvGrpSpPr>
+        <p:cNvPr id="1" name=""/>
+        <p:cNvGrpSpPr/>
+        <p:nvPr/>
+      </p:nvGrpSpPr>
+      <p:grpSpPr>
+        <a:xfrm>
+          <a:off x="0" y="0"/>
+          <a:ext cx="0" cy="0"/>
+          <a:chOff x="0" y="0"/>
+          <a:chExt cx="0" cy="0"/>
+        </a:xfrm>
+      </p:grpSpPr>
+      <p:sp>
+        <p:nvSpPr>
+          <p:cNvPr id="2" name="Title 1">
+            <a:extLst>
+              <a:ext uri="{FF2B5EF4-FFF2-40B4-BE49-F238E27FC236}">
+                <a16:creationId xmlns:a16="http://schemas.microsoft.com/office/drawing/2014/main" id="{C2345478-FD46-ED91-A430-991C8D0B7F44}"/>
+              </a:ext>
+            </a:extLst>
+          </p:cNvPr>
+          <p:cNvSpPr>
+            <a:spLocks noGrp="1"/>
+          </p:cNvSpPr>
+          <p:nvPr>
+            <p:ph type="title"/>
+          </p:nvPr>
+        </p:nvSpPr>
+        <p:spPr/>
+        <p:txBody>
+          <a:bodyPr>
+            <a:normAutofit fontScale="90000"/>
+          </a:bodyPr>
+          <a:lstStyle/>
+          <a:p>
+            <a:r>
+              <a:rPr lang="en-US" dirty="0"/>
+              <a:t>Constraints Among Characteristics</a:t>
+            </a:r>
+          </a:p>
+        </p:txBody>
+      </p:sp>
+      <p:sp>
+        <p:nvSpPr>
+          <p:cNvPr id="3" name="Text Placeholder 2">
+            <a:extLst>
+              <a:ext uri="{FF2B5EF4-FFF2-40B4-BE49-F238E27FC236}">
+                <a16:creationId xmlns:a16="http://schemas.microsoft.com/office/drawing/2014/main" id="{E857CC02-A2AC-AC7A-3CCF-4836EC4D0FA6}"/>
+              </a:ext>
+            </a:extLst>
+          </p:cNvPr>
+          <p:cNvSpPr>
+            <a:spLocks noGrp="1"/>
+          </p:cNvSpPr>
+          <p:nvPr>
+            <p:ph type="body" idx="1"/>
+          </p:nvPr>
+        </p:nvSpPr>
+        <p:spPr/>
+        <p:txBody>
+          <a:bodyPr/>
+          <a:lstStyle/>
+          <a:p>
+            <a:r>
+              <a:rPr lang="en-US" dirty="0"/>
+              <a:t>Some combinations of blocks are infeasible</a:t>
+            </a:r>
+          </a:p>
+          <a:p>
+            <a:r>
+              <a:rPr lang="en-US" dirty="0"/>
+              <a:t>These are represented as constraints among blocks</a:t>
+            </a:r>
+          </a:p>
+          <a:p>
+            <a:endParaRPr lang="en-US" dirty="0"/>
+          </a:p>
+        </p:txBody>
+      </p:sp>
+      <p:sp>
+        <p:nvSpPr>
+          <p:cNvPr id="4" name="TextBox 3">
+            <a:extLst>
+              <a:ext uri="{FF2B5EF4-FFF2-40B4-BE49-F238E27FC236}">
+                <a16:creationId xmlns:a16="http://schemas.microsoft.com/office/drawing/2014/main" id="{F13CEE8D-DD52-05E8-ACC5-A9D9FA3BAE57}"/>
+              </a:ext>
+            </a:extLst>
+          </p:cNvPr>
+          <p:cNvSpPr txBox="1"/>
+          <p:nvPr/>
+        </p:nvSpPr>
+        <p:spPr>
+          <a:xfrm>
+            <a:off x="611893" y="1933517"/>
+            <a:ext cx="5088252" cy="738664"/>
+          </a:xfrm>
+          <a:prstGeom prst="rect">
+            <a:avLst/>
+          </a:prstGeom>
+          <a:noFill/>
+        </p:spPr>
+        <p:txBody>
+          <a:bodyPr wrap="none" rtlCol="0">
+            <a:spAutoFit/>
+          </a:bodyPr>
+          <a:lstStyle/>
+          <a:p>
+            <a:r>
+              <a:rPr lang="en-US" dirty="0"/>
+              <a:t>public </a:t>
+            </a:r>
+            <a:r>
+              <a:rPr lang="en-US" dirty="0" err="1"/>
+              <a:t>boolean</a:t>
+            </a:r>
+            <a:r>
+              <a:rPr lang="en-US" dirty="0"/>
+              <a:t> </a:t>
+            </a:r>
+            <a:r>
+              <a:rPr lang="en-US" dirty="0" err="1"/>
+              <a:t>findElement</a:t>
+            </a:r>
+            <a:r>
+              <a:rPr lang="en-US" dirty="0"/>
+              <a:t> (List </a:t>
+            </a:r>
+            <a:r>
+              <a:rPr lang="en-US" dirty="0" err="1"/>
+              <a:t>list</a:t>
+            </a:r>
+            <a:r>
+              <a:rPr lang="en-US" dirty="0"/>
+              <a:t>, Object element)</a:t>
+            </a:r>
+          </a:p>
+          <a:p>
+            <a:r>
+              <a:rPr lang="en-US" dirty="0"/>
+              <a:t>// Effects: if list or element is null throw </a:t>
+            </a:r>
+            <a:r>
+              <a:rPr lang="en-US" dirty="0" err="1"/>
+              <a:t>NullPointerException</a:t>
+            </a:r>
+            <a:endParaRPr lang="en-US" dirty="0"/>
+          </a:p>
+          <a:p>
+            <a:r>
+              <a:rPr lang="en-US" dirty="0"/>
+              <a:t>//           else return true if element is in the list, false otherwise</a:t>
+            </a:r>
+          </a:p>
+        </p:txBody>
+      </p:sp>
+      <p:pic>
+        <p:nvPicPr>
+          <p:cNvPr id="5" name="table">
+            <a:extLst>
+              <a:ext uri="{FF2B5EF4-FFF2-40B4-BE49-F238E27FC236}">
+                <a16:creationId xmlns:a16="http://schemas.microsoft.com/office/drawing/2014/main" id="{C39B86E6-0CC5-D4D5-A6DA-D476AE5B44E7}"/>
+              </a:ext>
+            </a:extLst>
+          </p:cNvPr>
+          <p:cNvPicPr>
+            <a:picLocks noChangeAspect="1"/>
+          </p:cNvPicPr>
+          <p:nvPr/>
+        </p:nvPicPr>
+        <p:blipFill>
+          <a:blip r:embed="rId2"/>
+          <a:stretch>
+            <a:fillRect/>
+          </a:stretch>
+        </p:blipFill>
+        <p:spPr>
+          <a:xfrm>
+            <a:off x="452361" y="2769333"/>
+            <a:ext cx="7158472" cy="2266026"/>
+          </a:xfrm>
+          <a:prstGeom prst="rect">
+            <a:avLst/>
+          </a:prstGeom>
+        </p:spPr>
+      </p:pic>
+    </p:spTree>
+    <p:extLst>
+      <p:ext uri="{BB962C8B-B14F-4D97-AF65-F5344CB8AC3E}">
+        <p14:creationId xmlns:p14="http://schemas.microsoft.com/office/powerpoint/2010/main" val="3168445713"/>
+      </p:ext>
+    </p:extLst>
+  </p:cSld>
+  <p:clrMapOvr>
+    <a:masterClrMapping/>
+  </p:clrMapOvr>
+</p:sld>
+</file>
+
+<file path=ppt/slides/slide42.xml><?xml version="1.0" encoding="utf-8"?>
+<p:sld xmlns:a="http://schemas.openxmlformats.org/drawingml/2006/main" xmlns:r="http://schemas.openxmlformats.org/officeDocument/2006/relationships" xmlns:p="http://schemas.openxmlformats.org/presentationml/2006/main">
+  <p:cSld>
+    <p:spTree>
+      <p:nvGrpSpPr>
+        <p:cNvPr id="1" name=""/>
+        <p:cNvGrpSpPr/>
+        <p:nvPr/>
+      </p:nvGrpSpPr>
+      <p:grpSpPr>
+        <a:xfrm>
+          <a:off x="0" y="0"/>
+          <a:ext cx="0" cy="0"/>
+          <a:chOff x="0" y="0"/>
+          <a:chExt cx="0" cy="0"/>
+        </a:xfrm>
+      </p:grpSpPr>
+      <p:sp>
+        <p:nvSpPr>
+          <p:cNvPr id="2" name="Title 1">
+            <a:extLst>
+              <a:ext uri="{FF2B5EF4-FFF2-40B4-BE49-F238E27FC236}">
+                <a16:creationId xmlns:a16="http://schemas.microsoft.com/office/drawing/2014/main" id="{8EFF8F21-ACEF-ED16-14E2-5A10F3A6C686}"/>
+              </a:ext>
+            </a:extLst>
+          </p:cNvPr>
+          <p:cNvSpPr>
+            <a:spLocks noGrp="1"/>
+          </p:cNvSpPr>
+          <p:nvPr>
+            <p:ph type="title"/>
+          </p:nvPr>
+        </p:nvSpPr>
+        <p:spPr/>
+        <p:txBody>
+          <a:bodyPr>
+            <a:normAutofit fontScale="90000"/>
+          </a:bodyPr>
+          <a:lstStyle/>
+          <a:p>
+            <a:r>
+              <a:rPr lang="en-US" dirty="0"/>
+              <a:t>Input Space Partitioning Summary</a:t>
+            </a:r>
+          </a:p>
+        </p:txBody>
+      </p:sp>
+      <p:sp>
+        <p:nvSpPr>
+          <p:cNvPr id="3" name="Text Placeholder 2">
+            <a:extLst>
+              <a:ext uri="{FF2B5EF4-FFF2-40B4-BE49-F238E27FC236}">
+                <a16:creationId xmlns:a16="http://schemas.microsoft.com/office/drawing/2014/main" id="{C773C5DC-80FD-A64D-99C4-B88175301DFD}"/>
+              </a:ext>
+            </a:extLst>
+          </p:cNvPr>
+          <p:cNvSpPr>
+            <a:spLocks noGrp="1"/>
+          </p:cNvSpPr>
+          <p:nvPr>
+            <p:ph type="body" idx="1"/>
+          </p:nvPr>
+        </p:nvSpPr>
+        <p:spPr/>
+        <p:txBody>
+          <a:bodyPr/>
+          <a:lstStyle/>
+          <a:p>
+            <a:r>
+              <a:rPr lang="en-US" dirty="0"/>
+              <a:t>Fairly easy to apply, even with no automation</a:t>
+            </a:r>
+          </a:p>
+          <a:p>
+            <a:r>
+              <a:rPr lang="en-US" dirty="0"/>
+              <a:t>Convenient ways to add more or less testing</a:t>
+            </a:r>
+          </a:p>
+          <a:p>
+            <a:r>
+              <a:rPr lang="en-US" dirty="0"/>
+              <a:t>Applicable to all levels of testing – unit, class, integration, system, etc.</a:t>
+            </a:r>
+          </a:p>
+          <a:p>
+            <a:r>
+              <a:rPr lang="en-US" dirty="0"/>
+              <a:t>Based only on the input space of the program, not the implementation</a:t>
+            </a:r>
+          </a:p>
+          <a:p>
+            <a:r>
+              <a:rPr lang="en-US" dirty="0"/>
+              <a:t>Simple, straightforward, effective, and widely used</a:t>
+            </a:r>
+          </a:p>
+        </p:txBody>
+      </p:sp>
+    </p:spTree>
+    <p:extLst>
+      <p:ext uri="{BB962C8B-B14F-4D97-AF65-F5344CB8AC3E}">
+        <p14:creationId xmlns:p14="http://schemas.microsoft.com/office/powerpoint/2010/main" val="3686691840"/>
+      </p:ext>
+    </p:extLst>
   </p:cSld>
   <p:clrMapOvr>
     <a:masterClrMapping/>

</xml_diff>